<commit_message>
Add pressure index, SISREG live feed, multilevel alerts, and panorama deck.
Wire IndicaSUS/SISREG/SINAN/SIM into Assistência (G/A/V + 7d trend), persist multinível alert payloads, and ship operational docs/presentations with real panel snapshots.

Co-authored-by: Cursor <cursoragent@cursor.com>
</commit_message>
<xml_diff>
--- a/docs/apresentacoes/Apresentacao_SIS_Clima_Saude_20min.pptx
+++ b/docs/apresentacoes/Apresentacao_SIS_Clima_Saude_20min.pptx
@@ -19,6 +19,10 @@
     <p:sldId id="267" r:id="rId19"/>
     <p:sldId id="268" r:id="rId20"/>
     <p:sldId id="269" r:id="rId21"/>
+    <p:sldId id="270" r:id="rId22"/>
+    <p:sldId id="271" r:id="rId23"/>
+    <p:sldId id="272" r:id="rId24"/>
+    <p:sldId id="273" r:id="rId25"/>
   </p:sldIdLst>
   <p:sldSz cx="12191695" cy="6858000" type="screen4x3"/>
   <p:notesSz cx="6858000" cy="9144000"/>
@@ -795,7 +799,7 @@
           <a:lstStyle/>
           <a:p>
             <a:r>
-              <a:t>ROTEIRO (2 min): Peça donos: CIEVS (rotina), TI (rede), assistência (ocupação).</a:t>
+              <a:t>ROTEIRO (2 min): Mostre o DOC-WA nos níveis e diga que o SIS é o radar diário.</a:t>
             </a:r>
           </a:p>
         </p:txBody>
@@ -821,6 +825,286 @@
 </file>
 
 <file path=ppt/notesSlides/notesSlide14.xml><?xml version="1.0" encoding="utf-8"?>
+<p:notes xmlns:a="http://schemas.openxmlformats.org/drawingml/2006/main" xmlns:p="http://schemas.openxmlformats.org/presentationml/2006/main" xmlns:r="http://schemas.openxmlformats.org/officeDocument/2006/relationships">
+  <p:cSld>
+    <p:spTree>
+      <p:nvGrpSpPr>
+        <p:cNvPr id="1" name=""/>
+        <p:cNvGrpSpPr/>
+        <p:nvPr/>
+      </p:nvGrpSpPr>
+      <p:grpSpPr>
+        <a:xfrm>
+          <a:off x="0" y="0"/>
+          <a:ext cx="0" cy="0"/>
+          <a:chOff x="0" y="0"/>
+          <a:chExt cx="0" cy="0"/>
+        </a:xfrm>
+      </p:grpSpPr>
+      <p:sp>
+        <p:nvSpPr>
+          <p:cNvPr id="2" name="Slide Image Placeholder 1"/>
+          <p:cNvSpPr>
+            <a:spLocks noGrp="1"/>
+          </p:cNvSpPr>
+          <p:nvPr>
+            <p:ph type="sldImg" idx="2"/>
+          </p:nvPr>
+        </p:nvSpPr>
+        <p:spPr/>
+      </p:sp>
+      <p:sp>
+        <p:nvSpPr>
+          <p:cNvPr id="3" name="Notes Placeholder 2"/>
+          <p:cNvSpPr>
+            <a:spLocks noGrp="1"/>
+          </p:cNvSpPr>
+          <p:nvPr>
+            <p:ph type="body" idx="3" sz="quarter"/>
+          </p:nvPr>
+        </p:nvSpPr>
+        <p:spPr/>
+        <p:txBody>
+          <a:bodyPr/>
+          <a:lstStyle/>
+          <a:p>
+            <a:r>
+              <a:t>ROTEIRO (1,5 min): Imprima este slide como cartão de plantão.</a:t>
+            </a:r>
+          </a:p>
+        </p:txBody>
+      </p:sp>
+      <p:sp>
+        <p:nvSpPr>
+          <p:cNvPr id="4" name="Slide Number Placeholder 3"/>
+          <p:cNvSpPr>
+            <a:spLocks noGrp="1"/>
+          </p:cNvSpPr>
+          <p:nvPr>
+            <p:ph type="sldNum" idx="5" sz="quarter"/>
+          </p:nvPr>
+        </p:nvSpPr>
+        <p:spPr/>
+      </p:sp>
+    </p:spTree>
+  </p:cSld>
+  <p:clrMapOvr>
+    <a:masterClrMapping/>
+  </p:clrMapOvr>
+</p:notes>
+</file>
+
+<file path=ppt/notesSlides/notesSlide15.xml><?xml version="1.0" encoding="utf-8"?>
+<p:notes xmlns:a="http://schemas.openxmlformats.org/drawingml/2006/main" xmlns:p="http://schemas.openxmlformats.org/presentationml/2006/main" xmlns:r="http://schemas.openxmlformats.org/officeDocument/2006/relationships">
+  <p:cSld>
+    <p:spTree>
+      <p:nvGrpSpPr>
+        <p:cNvPr id="1" name=""/>
+        <p:cNvGrpSpPr/>
+        <p:nvPr/>
+      </p:nvGrpSpPr>
+      <p:grpSpPr>
+        <a:xfrm>
+          <a:off x="0" y="0"/>
+          <a:ext cx="0" cy="0"/>
+          <a:chOff x="0" y="0"/>
+          <a:chExt cx="0" cy="0"/>
+        </a:xfrm>
+      </p:grpSpPr>
+      <p:sp>
+        <p:nvSpPr>
+          <p:cNvPr id="2" name="Slide Image Placeholder 1"/>
+          <p:cNvSpPr>
+            <a:spLocks noGrp="1"/>
+          </p:cNvSpPr>
+          <p:nvPr>
+            <p:ph type="sldImg" idx="2"/>
+          </p:nvPr>
+        </p:nvSpPr>
+        <p:spPr/>
+      </p:sp>
+      <p:sp>
+        <p:nvSpPr>
+          <p:cNvPr id="3" name="Notes Placeholder 2"/>
+          <p:cNvSpPr>
+            <a:spLocks noGrp="1"/>
+          </p:cNvSpPr>
+          <p:nvPr>
+            <p:ph type="body" idx="3" sz="quarter"/>
+          </p:nvPr>
+        </p:nvSpPr>
+        <p:spPr/>
+        <p:txBody>
+          <a:bodyPr/>
+          <a:lstStyle/>
+          <a:p>
+            <a:r>
+              <a:t>ROTEIRO (1 min): Reforce estabilidade após refatoração.</a:t>
+            </a:r>
+          </a:p>
+        </p:txBody>
+      </p:sp>
+      <p:sp>
+        <p:nvSpPr>
+          <p:cNvPr id="4" name="Slide Number Placeholder 3"/>
+          <p:cNvSpPr>
+            <a:spLocks noGrp="1"/>
+          </p:cNvSpPr>
+          <p:nvPr>
+            <p:ph type="sldNum" idx="5" sz="quarter"/>
+          </p:nvPr>
+        </p:nvSpPr>
+        <p:spPr/>
+      </p:sp>
+    </p:spTree>
+  </p:cSld>
+  <p:clrMapOvr>
+    <a:masterClrMapping/>
+  </p:clrMapOvr>
+</p:notes>
+</file>
+
+<file path=ppt/notesSlides/notesSlide16.xml><?xml version="1.0" encoding="utf-8"?>
+<p:notes xmlns:a="http://schemas.openxmlformats.org/drawingml/2006/main" xmlns:p="http://schemas.openxmlformats.org/presentationml/2006/main" xmlns:r="http://schemas.openxmlformats.org/officeDocument/2006/relationships">
+  <p:cSld>
+    <p:spTree>
+      <p:nvGrpSpPr>
+        <p:cNvPr id="1" name=""/>
+        <p:cNvGrpSpPr/>
+        <p:nvPr/>
+      </p:nvGrpSpPr>
+      <p:grpSpPr>
+        <a:xfrm>
+          <a:off x="0" y="0"/>
+          <a:ext cx="0" cy="0"/>
+          <a:chOff x="0" y="0"/>
+          <a:chExt cx="0" cy="0"/>
+        </a:xfrm>
+      </p:grpSpPr>
+      <p:sp>
+        <p:nvSpPr>
+          <p:cNvPr id="2" name="Slide Image Placeholder 1"/>
+          <p:cNvSpPr>
+            <a:spLocks noGrp="1"/>
+          </p:cNvSpPr>
+          <p:nvPr>
+            <p:ph type="sldImg" idx="2"/>
+          </p:nvPr>
+        </p:nvSpPr>
+        <p:spPr/>
+      </p:sp>
+      <p:sp>
+        <p:nvSpPr>
+          <p:cNvPr id="3" name="Notes Placeholder 2"/>
+          <p:cNvSpPr>
+            <a:spLocks noGrp="1"/>
+          </p:cNvSpPr>
+          <p:nvPr>
+            <p:ph type="body" idx="3" sz="quarter"/>
+          </p:nvPr>
+        </p:nvSpPr>
+        <p:spPr/>
+        <p:txBody>
+          <a:bodyPr/>
+          <a:lstStyle/>
+          <a:p>
+            <a:r>
+              <a:t>ROTEIRO (2 min): Mostre a aba Alertas no painel — abas ①②③④.</a:t>
+            </a:r>
+          </a:p>
+        </p:txBody>
+      </p:sp>
+      <p:sp>
+        <p:nvSpPr>
+          <p:cNvPr id="4" name="Slide Number Placeholder 3"/>
+          <p:cNvSpPr>
+            <a:spLocks noGrp="1"/>
+          </p:cNvSpPr>
+          <p:nvPr>
+            <p:ph type="sldNum" idx="5" sz="quarter"/>
+          </p:nvPr>
+        </p:nvSpPr>
+        <p:spPr/>
+      </p:sp>
+    </p:spTree>
+  </p:cSld>
+  <p:clrMapOvr>
+    <a:masterClrMapping/>
+  </p:clrMapOvr>
+</p:notes>
+</file>
+
+<file path=ppt/notesSlides/notesSlide17.xml><?xml version="1.0" encoding="utf-8"?>
+<p:notes xmlns:a="http://schemas.openxmlformats.org/drawingml/2006/main" xmlns:p="http://schemas.openxmlformats.org/presentationml/2006/main" xmlns:r="http://schemas.openxmlformats.org/officeDocument/2006/relationships">
+  <p:cSld>
+    <p:spTree>
+      <p:nvGrpSpPr>
+        <p:cNvPr id="1" name=""/>
+        <p:cNvGrpSpPr/>
+        <p:nvPr/>
+      </p:nvGrpSpPr>
+      <p:grpSpPr>
+        <a:xfrm>
+          <a:off x="0" y="0"/>
+          <a:ext cx="0" cy="0"/>
+          <a:chOff x="0" y="0"/>
+          <a:chExt cx="0" cy="0"/>
+        </a:xfrm>
+      </p:grpSpPr>
+      <p:sp>
+        <p:nvSpPr>
+          <p:cNvPr id="2" name="Slide Image Placeholder 1"/>
+          <p:cNvSpPr>
+            <a:spLocks noGrp="1"/>
+          </p:cNvSpPr>
+          <p:nvPr>
+            <p:ph type="sldImg" idx="2"/>
+          </p:nvPr>
+        </p:nvSpPr>
+        <p:spPr/>
+      </p:sp>
+      <p:sp>
+        <p:nvSpPr>
+          <p:cNvPr id="3" name="Notes Placeholder 2"/>
+          <p:cNvSpPr>
+            <a:spLocks noGrp="1"/>
+          </p:cNvSpPr>
+          <p:nvPr>
+            <p:ph type="body" idx="3" sz="quarter"/>
+          </p:nvPr>
+        </p:nvSpPr>
+        <p:spPr/>
+        <p:txBody>
+          <a:bodyPr/>
+          <a:lstStyle/>
+          <a:p>
+            <a:r>
+              <a:t>ROTEIRO (2 min): Peça donos: CIEVS (rotina), TI (rede), assistência (ocupação).</a:t>
+            </a:r>
+          </a:p>
+        </p:txBody>
+      </p:sp>
+      <p:sp>
+        <p:nvSpPr>
+          <p:cNvPr id="4" name="Slide Number Placeholder 3"/>
+          <p:cNvSpPr>
+            <a:spLocks noGrp="1"/>
+          </p:cNvSpPr>
+          <p:nvPr>
+            <p:ph type="sldNum" idx="5" sz="quarter"/>
+          </p:nvPr>
+        </p:nvSpPr>
+        <p:spPr/>
+      </p:sp>
+    </p:spTree>
+  </p:cSld>
+  <p:clrMapOvr>
+    <a:masterClrMapping/>
+  </p:clrMapOvr>
+</p:notes>
+</file>
+
+<file path=ppt/notesSlides/notesSlide18.xml><?xml version="1.0" encoding="utf-8"?>
 <p:notes xmlns:a="http://schemas.openxmlformats.org/drawingml/2006/main" xmlns:p="http://schemas.openxmlformats.org/presentationml/2006/main" xmlns:r="http://schemas.openxmlformats.org/officeDocument/2006/relationships">
   <p:cSld>
     <p:spTree>
@@ -5213,7 +5497,7 @@
                 </a:solidFill>
                 <a:latin typeface="Calibri"/>
               </a:rPr>
-              <a:t>10/14</a:t>
+              <a:t>10/18</a:t>
             </a:r>
           </a:p>
         </p:txBody>
@@ -5544,7 +5828,7 @@
                 </a:solidFill>
                 <a:latin typeface="Calibri"/>
               </a:rPr>
-              <a:t>11/14</a:t>
+              <a:t>11/18</a:t>
             </a:r>
           </a:p>
         </p:txBody>
@@ -5875,7 +6159,7 @@
                 </a:solidFill>
                 <a:latin typeface="Calibri"/>
               </a:rPr>
-              <a:t>12/14</a:t>
+              <a:t>12/18</a:t>
             </a:r>
           </a:p>
         </p:txBody>
@@ -6014,7 +6298,7 @@
                 </a:solidFill>
                 <a:latin typeface="Calibri"/>
               </a:rPr>
-              <a:t>Próximos passos</a:t>
+              <a:t>Ponte operacional: Plano × SIS</a:t>
             </a:r>
           </a:p>
         </p:txBody>
@@ -6049,21 +6333,109 @@
                 </a:solidFill>
                 <a:latin typeface="Calibri"/>
               </a:rPr>
-              <a:t>Do painel à rotina do CIEVS</a:t>
-            </a:r>
-          </a:p>
-        </p:txBody>
-      </p:sp>
-      <p:sp>
-        <p:nvSpPr>
-          <p:cNvPr id="6" name="TextBox 5"/>
+              <a:t>Correspondência prudente — não é equivalência jurídica automática</a:t>
+            </a:r>
+          </a:p>
+        </p:txBody>
+      </p:sp>
+      <p:sp>
+        <p:nvSpPr>
+          <p:cNvPr id="6" name="Rounded Rectangle 5"/>
+          <p:cNvSpPr/>
+          <p:nvPr/>
+        </p:nvSpPr>
+        <p:spPr>
+          <a:xfrm>
+            <a:off x="457200" y="1280160"/>
+            <a:ext cx="3657600" cy="1051560"/>
+          </a:xfrm>
+          <a:prstGeom prst="roundRect">
+            <a:avLst/>
+          </a:prstGeom>
+          <a:solidFill>
+            <a:srgbClr val="FFFFFF"/>
+          </a:solidFill>
+          <a:ln>
+            <a:solidFill>
+              <a:srgbClr val="D5E0DA"/>
+            </a:solidFill>
+          </a:ln>
+        </p:spPr>
+        <p:style>
+          <a:lnRef idx="1">
+            <a:schemeClr val="accent1"/>
+          </a:lnRef>
+          <a:fillRef idx="3">
+            <a:schemeClr val="accent1"/>
+          </a:fillRef>
+          <a:effectRef idx="2">
+            <a:schemeClr val="accent1"/>
+          </a:effectRef>
+          <a:fontRef idx="minor">
+            <a:schemeClr val="lt1"/>
+          </a:fontRef>
+        </p:style>
+        <p:txBody>
+          <a:bodyPr rtlCol="0" anchor="ctr"/>
+          <a:lstStyle/>
+          <a:p>
+            <a:pPr algn="ctr"/>
+          </a:p>
+        </p:txBody>
+      </p:sp>
+      <p:sp>
+        <p:nvSpPr>
+          <p:cNvPr id="7" name="Rectangle 6"/>
+          <p:cNvSpPr/>
+          <p:nvPr/>
+        </p:nvSpPr>
+        <p:spPr>
+          <a:xfrm>
+            <a:off x="457200" y="1280160"/>
+            <a:ext cx="109728" cy="1051560"/>
+          </a:xfrm>
+          <a:prstGeom prst="rect">
+            <a:avLst/>
+          </a:prstGeom>
+          <a:solidFill>
+            <a:srgbClr val="0F6E56"/>
+          </a:solidFill>
+          <a:ln>
+            <a:noFill/>
+          </a:ln>
+        </p:spPr>
+        <p:style>
+          <a:lnRef idx="1">
+            <a:schemeClr val="accent1"/>
+          </a:lnRef>
+          <a:fillRef idx="3">
+            <a:schemeClr val="accent1"/>
+          </a:fillRef>
+          <a:effectRef idx="2">
+            <a:schemeClr val="accent1"/>
+          </a:effectRef>
+          <a:fontRef idx="minor">
+            <a:schemeClr val="lt1"/>
+          </a:fontRef>
+        </p:style>
+        <p:txBody>
+          <a:bodyPr rtlCol="0" anchor="ctr"/>
+          <a:lstStyle/>
+          <a:p>
+            <a:pPr algn="ctr"/>
+          </a:p>
+        </p:txBody>
+      </p:sp>
+      <p:sp>
+        <p:nvSpPr>
+          <p:cNvPr id="8" name="TextBox 7"/>
           <p:cNvSpPr txBox="1"/>
           <p:nvPr/>
         </p:nvSpPr>
         <p:spPr>
           <a:xfrm>
-            <a:off x="502920" y="1280160"/>
-            <a:ext cx="11155680" cy="4572000"/>
+            <a:off x="713232" y="1417319"/>
+            <a:ext cx="3291840" cy="320040"/>
           </a:xfrm>
           <a:prstGeom prst="rect">
             <a:avLst/>
@@ -6076,97 +6448,29 @@
           </a:bodyPr>
           <a:lstStyle/>
           <a:p>
-            <a:pPr algn="l">
-              <a:spcAft>
-                <a:spcPts val="800"/>
-              </a:spcAft>
-            </a:pPr>
-            <a:r>
-              <a:rPr sz="1800" b="0">
-                <a:solidFill>
-                  <a:srgbClr val="1A2E28"/>
-                </a:solidFill>
-                <a:latin typeface="Calibri"/>
-              </a:rPr>
-              <a:t>• Padronizar abertura do painel no plantão (checklist de 5 minutos).</a:t>
-            </a:r>
-          </a:p>
-          <a:p>
-            <a:pPr algn="l">
-              <a:spcAft>
-                <a:spcPts val="800"/>
-              </a:spcAft>
-            </a:pPr>
-            <a:r>
-              <a:rPr sz="1800" b="0">
-                <a:solidFill>
-                  <a:srgbClr val="1A2E28"/>
-                </a:solidFill>
-                <a:latin typeface="Calibri"/>
-              </a:rPr>
-              <a:t>• Integrar envio de alertas (e-mail/Telegram) com validação humana.</a:t>
-            </a:r>
-          </a:p>
-          <a:p>
-            <a:pPr algn="l">
-              <a:spcAft>
-                <a:spcPts val="800"/>
-              </a:spcAft>
-            </a:pPr>
-            <a:r>
-              <a:rPr sz="1800" b="0">
-                <a:solidFill>
-                  <a:srgbClr val="1A2E28"/>
-                </a:solidFill>
-                <a:latin typeface="Calibri"/>
-              </a:rPr>
-              <a:t>• Treinar regionais na leitura de mapas e níveis (linguagem simples).</a:t>
-            </a:r>
-          </a:p>
-          <a:p>
-            <a:pPr algn="l">
-              <a:spcAft>
-                <a:spcPts val="800"/>
-              </a:spcAft>
-            </a:pPr>
-            <a:r>
-              <a:rPr sz="1800" b="0">
-                <a:solidFill>
-                  <a:srgbClr val="1A2E28"/>
-                </a:solidFill>
-                <a:latin typeface="Calibri"/>
-              </a:rPr>
-              <a:t>• Manter atualização do enriquecimento operacional e da base Postgres.</a:t>
-            </a:r>
-          </a:p>
-          <a:p>
-            <a:pPr algn="l">
-              <a:spcAft>
-                <a:spcPts val="800"/>
-              </a:spcAft>
-            </a:pPr>
-            <a:r>
-              <a:rPr sz="1800" b="0">
-                <a:solidFill>
-                  <a:srgbClr val="1A2E28"/>
-                </a:solidFill>
-                <a:latin typeface="Calibri"/>
-              </a:rPr>
-              <a:t>• Articular indicadores do SIS aos gatilhos do Plano de Contingência (mesa técnica).</a:t>
-            </a:r>
-          </a:p>
-        </p:txBody>
-      </p:sp>
-      <p:sp>
-        <p:nvSpPr>
-          <p:cNvPr id="7" name="TextBox 6"/>
+            <a:pPr algn="l"/>
+            <a:r>
+              <a:rPr sz="1400" b="1">
+                <a:solidFill>
+                  <a:srgbClr val="08352E"/>
+                </a:solidFill>
+                <a:latin typeface="Calibri"/>
+              </a:rPr>
+              <a:t>Plano Nível 0</a:t>
+            </a:r>
+          </a:p>
+        </p:txBody>
+      </p:sp>
+      <p:sp>
+        <p:nvSpPr>
+          <p:cNvPr id="9" name="TextBox 8"/>
           <p:cNvSpPr txBox="1"/>
           <p:nvPr/>
         </p:nvSpPr>
         <p:spPr>
           <a:xfrm>
-            <a:off x="411480" y="6492240"/>
-            <a:ext cx="9144000" cy="274320"/>
+            <a:off x="713232" y="1737360"/>
+            <a:ext cx="3291840" cy="457199"/>
           </a:xfrm>
           <a:prstGeom prst="rect">
             <a:avLst/>
@@ -6181,27 +6485,115 @@
           <a:p>
             <a:pPr algn="l"/>
             <a:r>
-              <a:rPr sz="1000" b="0">
-                <a:solidFill>
-                  <a:srgbClr val="4B5C56"/>
-                </a:solidFill>
-                <a:latin typeface="Calibri"/>
-              </a:rPr>
-              <a:t>CIEVS-MT · SIS Clima-Saúde · Código legível · Fontes oficiais</a:t>
-            </a:r>
-          </a:p>
-        </p:txBody>
-      </p:sp>
-      <p:sp>
-        <p:nvSpPr>
-          <p:cNvPr id="8" name="TextBox 7"/>
+              <a:rPr sz="1300" b="0">
+                <a:solidFill>
+                  <a:srgbClr val="1A2E28"/>
+                </a:solidFill>
+                <a:latin typeface="Calibri"/>
+              </a:rPr>
+              <a:t>SIS Verde → Rotina / monitoramento</a:t>
+            </a:r>
+          </a:p>
+        </p:txBody>
+      </p:sp>
+      <p:sp>
+        <p:nvSpPr>
+          <p:cNvPr id="10" name="Rounded Rectangle 9"/>
+          <p:cNvSpPr/>
+          <p:nvPr/>
+        </p:nvSpPr>
+        <p:spPr>
+          <a:xfrm>
+            <a:off x="457200" y="2468880"/>
+            <a:ext cx="3657600" cy="1051560"/>
+          </a:xfrm>
+          <a:prstGeom prst="roundRect">
+            <a:avLst/>
+          </a:prstGeom>
+          <a:solidFill>
+            <a:srgbClr val="FFFFFF"/>
+          </a:solidFill>
+          <a:ln>
+            <a:solidFill>
+              <a:srgbClr val="D5E0DA"/>
+            </a:solidFill>
+          </a:ln>
+        </p:spPr>
+        <p:style>
+          <a:lnRef idx="1">
+            <a:schemeClr val="accent1"/>
+          </a:lnRef>
+          <a:fillRef idx="3">
+            <a:schemeClr val="accent1"/>
+          </a:fillRef>
+          <a:effectRef idx="2">
+            <a:schemeClr val="accent1"/>
+          </a:effectRef>
+          <a:fontRef idx="minor">
+            <a:schemeClr val="lt1"/>
+          </a:fontRef>
+        </p:style>
+        <p:txBody>
+          <a:bodyPr rtlCol="0" anchor="ctr"/>
+          <a:lstStyle/>
+          <a:p>
+            <a:pPr algn="ctr"/>
+          </a:p>
+        </p:txBody>
+      </p:sp>
+      <p:sp>
+        <p:nvSpPr>
+          <p:cNvPr id="11" name="Rectangle 10"/>
+          <p:cNvSpPr/>
+          <p:nvPr/>
+        </p:nvSpPr>
+        <p:spPr>
+          <a:xfrm>
+            <a:off x="457200" y="2468880"/>
+            <a:ext cx="109728" cy="1051560"/>
+          </a:xfrm>
+          <a:prstGeom prst="rect">
+            <a:avLst/>
+          </a:prstGeom>
+          <a:solidFill>
+            <a:srgbClr val="0F6E56"/>
+          </a:solidFill>
+          <a:ln>
+            <a:noFill/>
+          </a:ln>
+        </p:spPr>
+        <p:style>
+          <a:lnRef idx="1">
+            <a:schemeClr val="accent1"/>
+          </a:lnRef>
+          <a:fillRef idx="3">
+            <a:schemeClr val="accent1"/>
+          </a:fillRef>
+          <a:effectRef idx="2">
+            <a:schemeClr val="accent1"/>
+          </a:effectRef>
+          <a:fontRef idx="minor">
+            <a:schemeClr val="lt1"/>
+          </a:fontRef>
+        </p:style>
+        <p:txBody>
+          <a:bodyPr rtlCol="0" anchor="ctr"/>
+          <a:lstStyle/>
+          <a:p>
+            <a:pPr algn="ctr"/>
+          </a:p>
+        </p:txBody>
+      </p:sp>
+      <p:sp>
+        <p:nvSpPr>
+          <p:cNvPr id="12" name="TextBox 11"/>
           <p:cNvSpPr txBox="1"/>
           <p:nvPr/>
         </p:nvSpPr>
         <p:spPr>
           <a:xfrm>
-            <a:off x="10241280" y="6492240"/>
-            <a:ext cx="1554480" cy="274320"/>
+            <a:off x="713232" y="2606040"/>
+            <a:ext cx="3291840" cy="320040"/>
           </a:xfrm>
           <a:prstGeom prst="rect">
             <a:avLst/>
@@ -6214,6 +6606,464 @@
           </a:bodyPr>
           <a:lstStyle/>
           <a:p>
+            <a:pPr algn="l"/>
+            <a:r>
+              <a:rPr sz="1400" b="1">
+                <a:solidFill>
+                  <a:srgbClr val="08352E"/>
+                </a:solidFill>
+                <a:latin typeface="Calibri"/>
+              </a:rPr>
+              <a:t>Plano Nível I</a:t>
+            </a:r>
+          </a:p>
+        </p:txBody>
+      </p:sp>
+      <p:sp>
+        <p:nvSpPr>
+          <p:cNvPr id="13" name="TextBox 12"/>
+          <p:cNvSpPr txBox="1"/>
+          <p:nvPr/>
+        </p:nvSpPr>
+        <p:spPr>
+          <a:xfrm>
+            <a:off x="713232" y="2926080"/>
+            <a:ext cx="3291840" cy="457199"/>
+          </a:xfrm>
+          <a:prstGeom prst="rect">
+            <a:avLst/>
+          </a:prstGeom>
+          <a:noFill/>
+        </p:spPr>
+        <p:txBody>
+          <a:bodyPr wrap="square">
+            <a:spAutoFit/>
+          </a:bodyPr>
+          <a:lstStyle/>
+          <a:p>
+            <a:pPr algn="l"/>
+            <a:r>
+              <a:rPr sz="1300" b="0">
+                <a:solidFill>
+                  <a:srgbClr val="1A2E28"/>
+                </a:solidFill>
+                <a:latin typeface="Calibri"/>
+              </a:rPr>
+              <a:t>SIS Amarela–Laranja → Mobilização / atenção</a:t>
+            </a:r>
+          </a:p>
+        </p:txBody>
+      </p:sp>
+      <p:sp>
+        <p:nvSpPr>
+          <p:cNvPr id="14" name="Rounded Rectangle 13"/>
+          <p:cNvSpPr/>
+          <p:nvPr/>
+        </p:nvSpPr>
+        <p:spPr>
+          <a:xfrm>
+            <a:off x="457200" y="3657600"/>
+            <a:ext cx="3657600" cy="1051560"/>
+          </a:xfrm>
+          <a:prstGeom prst="roundRect">
+            <a:avLst/>
+          </a:prstGeom>
+          <a:solidFill>
+            <a:srgbClr val="FFFFFF"/>
+          </a:solidFill>
+          <a:ln>
+            <a:solidFill>
+              <a:srgbClr val="D5E0DA"/>
+            </a:solidFill>
+          </a:ln>
+        </p:spPr>
+        <p:style>
+          <a:lnRef idx="1">
+            <a:schemeClr val="accent1"/>
+          </a:lnRef>
+          <a:fillRef idx="3">
+            <a:schemeClr val="accent1"/>
+          </a:fillRef>
+          <a:effectRef idx="2">
+            <a:schemeClr val="accent1"/>
+          </a:effectRef>
+          <a:fontRef idx="minor">
+            <a:schemeClr val="lt1"/>
+          </a:fontRef>
+        </p:style>
+        <p:txBody>
+          <a:bodyPr rtlCol="0" anchor="ctr"/>
+          <a:lstStyle/>
+          <a:p>
+            <a:pPr algn="ctr"/>
+          </a:p>
+        </p:txBody>
+      </p:sp>
+      <p:sp>
+        <p:nvSpPr>
+          <p:cNvPr id="15" name="Rectangle 14"/>
+          <p:cNvSpPr/>
+          <p:nvPr/>
+        </p:nvSpPr>
+        <p:spPr>
+          <a:xfrm>
+            <a:off x="457200" y="3657600"/>
+            <a:ext cx="109728" cy="1051560"/>
+          </a:xfrm>
+          <a:prstGeom prst="rect">
+            <a:avLst/>
+          </a:prstGeom>
+          <a:solidFill>
+            <a:srgbClr val="0F6E56"/>
+          </a:solidFill>
+          <a:ln>
+            <a:noFill/>
+          </a:ln>
+        </p:spPr>
+        <p:style>
+          <a:lnRef idx="1">
+            <a:schemeClr val="accent1"/>
+          </a:lnRef>
+          <a:fillRef idx="3">
+            <a:schemeClr val="accent1"/>
+          </a:fillRef>
+          <a:effectRef idx="2">
+            <a:schemeClr val="accent1"/>
+          </a:effectRef>
+          <a:fontRef idx="minor">
+            <a:schemeClr val="lt1"/>
+          </a:fontRef>
+        </p:style>
+        <p:txBody>
+          <a:bodyPr rtlCol="0" anchor="ctr"/>
+          <a:lstStyle/>
+          <a:p>
+            <a:pPr algn="ctr"/>
+          </a:p>
+        </p:txBody>
+      </p:sp>
+      <p:sp>
+        <p:nvSpPr>
+          <p:cNvPr id="16" name="TextBox 15"/>
+          <p:cNvSpPr txBox="1"/>
+          <p:nvPr/>
+        </p:nvSpPr>
+        <p:spPr>
+          <a:xfrm>
+            <a:off x="713232" y="3794760"/>
+            <a:ext cx="3291840" cy="320040"/>
+          </a:xfrm>
+          <a:prstGeom prst="rect">
+            <a:avLst/>
+          </a:prstGeom>
+          <a:noFill/>
+        </p:spPr>
+        <p:txBody>
+          <a:bodyPr wrap="square">
+            <a:spAutoFit/>
+          </a:bodyPr>
+          <a:lstStyle/>
+          <a:p>
+            <a:pPr algn="l"/>
+            <a:r>
+              <a:rPr sz="1400" b="1">
+                <a:solidFill>
+                  <a:srgbClr val="08352E"/>
+                </a:solidFill>
+                <a:latin typeface="Calibri"/>
+              </a:rPr>
+              <a:t>Plano Nível II</a:t>
+            </a:r>
+          </a:p>
+        </p:txBody>
+      </p:sp>
+      <p:sp>
+        <p:nvSpPr>
+          <p:cNvPr id="17" name="TextBox 16"/>
+          <p:cNvSpPr txBox="1"/>
+          <p:nvPr/>
+        </p:nvSpPr>
+        <p:spPr>
+          <a:xfrm>
+            <a:off x="713232" y="4114800"/>
+            <a:ext cx="3291840" cy="457199"/>
+          </a:xfrm>
+          <a:prstGeom prst="rect">
+            <a:avLst/>
+          </a:prstGeom>
+          <a:noFill/>
+        </p:spPr>
+        <p:txBody>
+          <a:bodyPr wrap="square">
+            <a:spAutoFit/>
+          </a:bodyPr>
+          <a:lstStyle/>
+          <a:p>
+            <a:pPr algn="l"/>
+            <a:r>
+              <a:rPr sz="1300" b="0">
+                <a:solidFill>
+                  <a:srgbClr val="1A2E28"/>
+                </a:solidFill>
+                <a:latin typeface="Calibri"/>
+              </a:rPr>
+              <a:t>SIS Laranja–Vermelha → Alerta / pressão</a:t>
+            </a:r>
+          </a:p>
+        </p:txBody>
+      </p:sp>
+      <p:sp>
+        <p:nvSpPr>
+          <p:cNvPr id="18" name="Rounded Rectangle 17"/>
+          <p:cNvSpPr/>
+          <p:nvPr/>
+        </p:nvSpPr>
+        <p:spPr>
+          <a:xfrm>
+            <a:off x="457200" y="4846320"/>
+            <a:ext cx="3657600" cy="1051560"/>
+          </a:xfrm>
+          <a:prstGeom prst="roundRect">
+            <a:avLst/>
+          </a:prstGeom>
+          <a:solidFill>
+            <a:srgbClr val="FFFFFF"/>
+          </a:solidFill>
+          <a:ln>
+            <a:solidFill>
+              <a:srgbClr val="D5E0DA"/>
+            </a:solidFill>
+          </a:ln>
+        </p:spPr>
+        <p:style>
+          <a:lnRef idx="1">
+            <a:schemeClr val="accent1"/>
+          </a:lnRef>
+          <a:fillRef idx="3">
+            <a:schemeClr val="accent1"/>
+          </a:fillRef>
+          <a:effectRef idx="2">
+            <a:schemeClr val="accent1"/>
+          </a:effectRef>
+          <a:fontRef idx="minor">
+            <a:schemeClr val="lt1"/>
+          </a:fontRef>
+        </p:style>
+        <p:txBody>
+          <a:bodyPr rtlCol="0" anchor="ctr"/>
+          <a:lstStyle/>
+          <a:p>
+            <a:pPr algn="ctr"/>
+          </a:p>
+        </p:txBody>
+      </p:sp>
+      <p:sp>
+        <p:nvSpPr>
+          <p:cNvPr id="19" name="Rectangle 18"/>
+          <p:cNvSpPr/>
+          <p:nvPr/>
+        </p:nvSpPr>
+        <p:spPr>
+          <a:xfrm>
+            <a:off x="457200" y="4846320"/>
+            <a:ext cx="109728" cy="1051560"/>
+          </a:xfrm>
+          <a:prstGeom prst="rect">
+            <a:avLst/>
+          </a:prstGeom>
+          <a:solidFill>
+            <a:srgbClr val="0F6E56"/>
+          </a:solidFill>
+          <a:ln>
+            <a:noFill/>
+          </a:ln>
+        </p:spPr>
+        <p:style>
+          <a:lnRef idx="1">
+            <a:schemeClr val="accent1"/>
+          </a:lnRef>
+          <a:fillRef idx="3">
+            <a:schemeClr val="accent1"/>
+          </a:fillRef>
+          <a:effectRef idx="2">
+            <a:schemeClr val="accent1"/>
+          </a:effectRef>
+          <a:fontRef idx="minor">
+            <a:schemeClr val="lt1"/>
+          </a:fontRef>
+        </p:style>
+        <p:txBody>
+          <a:bodyPr rtlCol="0" anchor="ctr"/>
+          <a:lstStyle/>
+          <a:p>
+            <a:pPr algn="ctr"/>
+          </a:p>
+        </p:txBody>
+      </p:sp>
+      <p:sp>
+        <p:nvSpPr>
+          <p:cNvPr id="20" name="TextBox 19"/>
+          <p:cNvSpPr txBox="1"/>
+          <p:nvPr/>
+        </p:nvSpPr>
+        <p:spPr>
+          <a:xfrm>
+            <a:off x="713232" y="4983480"/>
+            <a:ext cx="3291840" cy="320040"/>
+          </a:xfrm>
+          <a:prstGeom prst="rect">
+            <a:avLst/>
+          </a:prstGeom>
+          <a:noFill/>
+        </p:spPr>
+        <p:txBody>
+          <a:bodyPr wrap="square">
+            <a:spAutoFit/>
+          </a:bodyPr>
+          <a:lstStyle/>
+          <a:p>
+            <a:pPr algn="l"/>
+            <a:r>
+              <a:rPr sz="1400" b="1">
+                <a:solidFill>
+                  <a:srgbClr val="08352E"/>
+                </a:solidFill>
+                <a:latin typeface="Calibri"/>
+              </a:rPr>
+              <a:t>Plano Nível III–IV</a:t>
+            </a:r>
+          </a:p>
+        </p:txBody>
+      </p:sp>
+      <p:sp>
+        <p:nvSpPr>
+          <p:cNvPr id="21" name="TextBox 20"/>
+          <p:cNvSpPr txBox="1"/>
+          <p:nvPr/>
+        </p:nvSpPr>
+        <p:spPr>
+          <a:xfrm>
+            <a:off x="713232" y="5303520"/>
+            <a:ext cx="3291840" cy="457199"/>
+          </a:xfrm>
+          <a:prstGeom prst="rect">
+            <a:avLst/>
+          </a:prstGeom>
+          <a:noFill/>
+        </p:spPr>
+        <p:txBody>
+          <a:bodyPr wrap="square">
+            <a:spAutoFit/>
+          </a:bodyPr>
+          <a:lstStyle/>
+          <a:p>
+            <a:pPr algn="l"/>
+            <a:r>
+              <a:rPr sz="1300" b="0">
+                <a:solidFill>
+                  <a:srgbClr val="1A2E28"/>
+                </a:solidFill>
+                <a:latin typeface="Calibri"/>
+              </a:rPr>
+              <a:t>SIS Vermelha–Roxa → Emergência / articulação plena</a:t>
+            </a:r>
+          </a:p>
+        </p:txBody>
+      </p:sp>
+      <p:sp>
+        <p:nvSpPr>
+          <p:cNvPr id="22" name="TextBox 21"/>
+          <p:cNvSpPr txBox="1"/>
+          <p:nvPr/>
+        </p:nvSpPr>
+        <p:spPr>
+          <a:xfrm>
+            <a:off x="4389120" y="1371600"/>
+            <a:ext cx="7132320" cy="4572000"/>
+          </a:xfrm>
+          <a:prstGeom prst="rect">
+            <a:avLst/>
+          </a:prstGeom>
+          <a:noFill/>
+        </p:spPr>
+        <p:txBody>
+          <a:bodyPr wrap="square">
+            <a:spAutoFit/>
+          </a:bodyPr>
+          <a:lstStyle/>
+          <a:p>
+            <a:pPr algn="l"/>
+            <a:r>
+              <a:rPr sz="1600" b="0">
+                <a:solidFill>
+                  <a:srgbClr val="1A2E28"/>
+                </a:solidFill>
+                <a:latin typeface="Calibri"/>
+              </a:rPr>
+              <a:t>Use o SIS para priorizar município/regional e alimentar a Sala de Situação.
+A ativação formal de COE/Portarias continua nos fluxos do Plano e da gestão.
+O painel entrega: nível, motivo, orientação leiga, mapa e fila de atenção.</a:t>
+            </a:r>
+          </a:p>
+        </p:txBody>
+      </p:sp>
+      <p:sp>
+        <p:nvSpPr>
+          <p:cNvPr id="23" name="TextBox 22"/>
+          <p:cNvSpPr txBox="1"/>
+          <p:nvPr/>
+        </p:nvSpPr>
+        <p:spPr>
+          <a:xfrm>
+            <a:off x="411480" y="6492240"/>
+            <a:ext cx="9144000" cy="274320"/>
+          </a:xfrm>
+          <a:prstGeom prst="rect">
+            <a:avLst/>
+          </a:prstGeom>
+          <a:noFill/>
+        </p:spPr>
+        <p:txBody>
+          <a:bodyPr wrap="square">
+            <a:spAutoFit/>
+          </a:bodyPr>
+          <a:lstStyle/>
+          <a:p>
+            <a:pPr algn="l"/>
+            <a:r>
+              <a:rPr sz="1000" b="0">
+                <a:solidFill>
+                  <a:srgbClr val="4B5C56"/>
+                </a:solidFill>
+                <a:latin typeface="Calibri"/>
+              </a:rPr>
+              <a:t>CIEVS-MT · SIS Clima-Saúde · Código legível · Fontes oficiais</a:t>
+            </a:r>
+          </a:p>
+        </p:txBody>
+      </p:sp>
+      <p:sp>
+        <p:nvSpPr>
+          <p:cNvPr id="24" name="TextBox 23"/>
+          <p:cNvSpPr txBox="1"/>
+          <p:nvPr/>
+        </p:nvSpPr>
+        <p:spPr>
+          <a:xfrm>
+            <a:off x="10241280" y="6492240"/>
+            <a:ext cx="1554480" cy="274320"/>
+          </a:xfrm>
+          <a:prstGeom prst="rect">
+            <a:avLst/>
+          </a:prstGeom>
+          <a:noFill/>
+        </p:spPr>
+        <p:txBody>
+          <a:bodyPr wrap="square">
+            <a:spAutoFit/>
+          </a:bodyPr>
+          <a:lstStyle/>
+          <a:p>
             <a:pPr algn="r"/>
             <a:r>
               <a:rPr sz="1000" b="0">
@@ -6222,7 +7072,7 @@
                 </a:solidFill>
                 <a:latin typeface="Calibri"/>
               </a:rPr>
-              <a:t>13/14</a:t>
+              <a:t>13/18</a:t>
             </a:r>
           </a:p>
         </p:txBody>
@@ -6260,6 +7110,49 @@
             <a:avLst/>
           </a:prstGeom>
           <a:solidFill>
+            <a:srgbClr val="F3F6F4"/>
+          </a:solidFill>
+          <a:ln>
+            <a:noFill/>
+          </a:ln>
+        </p:spPr>
+        <p:style>
+          <a:lnRef idx="1">
+            <a:schemeClr val="accent1"/>
+          </a:lnRef>
+          <a:fillRef idx="3">
+            <a:schemeClr val="accent1"/>
+          </a:fillRef>
+          <a:effectRef idx="2">
+            <a:schemeClr val="accent1"/>
+          </a:effectRef>
+          <a:fontRef idx="minor">
+            <a:schemeClr val="lt1"/>
+          </a:fontRef>
+        </p:style>
+        <p:txBody>
+          <a:bodyPr rtlCol="0" anchor="ctr"/>
+          <a:lstStyle/>
+          <a:p>
+            <a:pPr algn="ctr"/>
+          </a:p>
+        </p:txBody>
+      </p:sp>
+      <p:sp>
+        <p:nvSpPr>
+          <p:cNvPr id="3" name="Rectangle 2"/>
+          <p:cNvSpPr/>
+          <p:nvPr/>
+        </p:nvSpPr>
+        <p:spPr>
+          <a:xfrm>
+            <a:off x="0" y="0"/>
+            <a:ext cx="12191695" cy="960120"/>
+          </a:xfrm>
+          <a:prstGeom prst="rect">
+            <a:avLst/>
+          </a:prstGeom>
+          <a:solidFill>
             <a:srgbClr val="08352E"/>
           </a:solidFill>
           <a:ln>
@@ -6290,14 +7183,14 @@
       </p:sp>
       <p:sp>
         <p:nvSpPr>
-          <p:cNvPr id="3" name="TextBox 2"/>
+          <p:cNvPr id="4" name="TextBox 3"/>
           <p:cNvSpPr txBox="1"/>
           <p:nvPr/>
         </p:nvSpPr>
         <p:spPr>
           <a:xfrm>
-            <a:off x="640080" y="1828800"/>
-            <a:ext cx="10972800" cy="731520"/>
+            <a:off x="411480" y="201168"/>
+            <a:ext cx="11155680" cy="411480"/>
           </a:xfrm>
           <a:prstGeom prst="rect">
             <a:avLst/>
@@ -6312,27 +7205,27 @@
           <a:p>
             <a:pPr algn="l"/>
             <a:r>
-              <a:rPr sz="4000" b="1">
+              <a:rPr sz="2600" b="1">
                 <a:solidFill>
                   <a:srgbClr val="FFFFFF"/>
                 </a:solidFill>
                 <a:latin typeface="Calibri"/>
               </a:rPr>
-              <a:t>Obrigado</a:t>
-            </a:r>
-          </a:p>
-        </p:txBody>
-      </p:sp>
-      <p:sp>
-        <p:nvSpPr>
-          <p:cNvPr id="4" name="TextBox 3"/>
+              <a:t>Checklist do plantão (5 minutos)</a:t>
+            </a:r>
+          </a:p>
+        </p:txBody>
+      </p:sp>
+      <p:sp>
+        <p:nvSpPr>
+          <p:cNvPr id="5" name="TextBox 4"/>
           <p:cNvSpPr txBox="1"/>
           <p:nvPr/>
         </p:nvSpPr>
         <p:spPr>
           <a:xfrm>
-            <a:off x="640080" y="2743200"/>
-            <a:ext cx="10972800" cy="1371600"/>
+            <a:off x="411480" y="566928"/>
+            <a:ext cx="11155680" cy="320040"/>
           </a:xfrm>
           <a:prstGeom prst="rect">
             <a:avLst/>
@@ -6347,28 +7240,27 @@
           <a:p>
             <a:pPr algn="l"/>
             <a:r>
-              <a:rPr sz="2000" b="0">
-                <a:solidFill>
-                  <a:srgbClr val="D7EBE3"/>
-                </a:solidFill>
-                <a:latin typeface="Calibri"/>
-              </a:rPr>
-              <a:t>SIS Clima-Saúde MT — vigilância para decidir a tempo.
-Perguntas e encaminhamentos.</a:t>
-            </a:r>
-          </a:p>
-        </p:txBody>
-      </p:sp>
-      <p:sp>
-        <p:nvSpPr>
-          <p:cNvPr id="5" name="TextBox 4"/>
+              <a:rPr sz="1300" b="0">
+                <a:solidFill>
+                  <a:srgbClr val="C8E6DC"/>
+                </a:solidFill>
+                <a:latin typeface="Calibri"/>
+              </a:rPr>
+              <a:t>Rotina mínima no CIEVS</a:t>
+            </a:r>
+          </a:p>
+        </p:txBody>
+      </p:sp>
+      <p:sp>
+        <p:nvSpPr>
+          <p:cNvPr id="6" name="TextBox 5"/>
           <p:cNvSpPr txBox="1"/>
           <p:nvPr/>
         </p:nvSpPr>
         <p:spPr>
           <a:xfrm>
-            <a:off x="640080" y="4754880"/>
-            <a:ext cx="10972800" cy="914400"/>
+            <a:off x="502920" y="1234440"/>
+            <a:ext cx="11155680" cy="4754880"/>
           </a:xfrm>
           <a:prstGeom prst="rect">
             <a:avLst/>
@@ -6381,8 +7273,1883 @@
           </a:bodyPr>
           <a:lstStyle/>
           <a:p>
+            <a:pPr algn="l">
+              <a:spcAft>
+                <a:spcPts val="800"/>
+              </a:spcAft>
+            </a:pPr>
+            <a:r>
+              <a:rPr sz="1800" b="0">
+                <a:solidFill>
+                  <a:srgbClr val="1A2E28"/>
+                </a:solidFill>
+                <a:latin typeface="Calibri"/>
+              </a:rPr>
+              <a:t>• 1. Abrir Visão executiva — ler nível estadual e município crítico.</a:t>
+            </a:r>
+          </a:p>
+          <a:p>
+            <a:pPr algn="l">
+              <a:spcAft>
+                <a:spcPts val="800"/>
+              </a:spcAft>
+            </a:pPr>
+            <a:r>
+              <a:rPr sz="1800" b="0">
+                <a:solidFill>
+                  <a:srgbClr val="1A2E28"/>
+                </a:solidFill>
+                <a:latin typeface="Calibri"/>
+              </a:rPr>
+              <a:t>• 2. Abrir Mapas — cloropleta de nível / tensão climática.</a:t>
+            </a:r>
+          </a:p>
+          <a:p>
+            <a:pPr algn="l">
+              <a:spcAft>
+                <a:spcPts val="800"/>
+              </a:spcAft>
+            </a:pPr>
+            <a:r>
+              <a:rPr sz="1800" b="0">
+                <a:solidFill>
+                  <a:srgbClr val="1A2E28"/>
+                </a:solidFill>
+                <a:latin typeface="Calibri"/>
+              </a:rPr>
+              <a:t>• 3. Abrir Clima/TITAN — solo, INMET/Cemaden, calor.</a:t>
+            </a:r>
+          </a:p>
+          <a:p>
+            <a:pPr algn="l">
+              <a:spcAft>
+                <a:spcPts val="800"/>
+              </a:spcAft>
+            </a:pPr>
+            <a:r>
+              <a:rPr sz="1800" b="0">
+                <a:solidFill>
+                  <a:srgbClr val="1A2E28"/>
+                </a:solidFill>
+                <a:latin typeface="Calibri"/>
+              </a:rPr>
+              <a:t>• 4. Abrir Alertas — fila de atenção e alerta integrado.</a:t>
+            </a:r>
+          </a:p>
+          <a:p>
+            <a:pPr algn="l">
+              <a:spcAft>
+                <a:spcPts val="800"/>
+              </a:spcAft>
+            </a:pPr>
+            <a:r>
+              <a:rPr sz="1800" b="0">
+                <a:solidFill>
+                  <a:srgbClr val="1A2E28"/>
+                </a:solidFill>
+                <a:latin typeface="Calibri"/>
+              </a:rPr>
+              <a:t>• 5. Registrar decisão (comunicado interno / encaminhamento à regional).</a:t>
+            </a:r>
+          </a:p>
+        </p:txBody>
+      </p:sp>
+      <p:sp>
+        <p:nvSpPr>
+          <p:cNvPr id="7" name="TextBox 6"/>
+          <p:cNvSpPr txBox="1"/>
+          <p:nvPr/>
+        </p:nvSpPr>
+        <p:spPr>
+          <a:xfrm>
+            <a:off x="411480" y="6492240"/>
+            <a:ext cx="9144000" cy="274320"/>
+          </a:xfrm>
+          <a:prstGeom prst="rect">
+            <a:avLst/>
+          </a:prstGeom>
+          <a:noFill/>
+        </p:spPr>
+        <p:txBody>
+          <a:bodyPr wrap="square">
+            <a:spAutoFit/>
+          </a:bodyPr>
+          <a:lstStyle/>
+          <a:p>
             <a:pPr algn="l"/>
             <a:r>
+              <a:rPr sz="1000" b="0">
+                <a:solidFill>
+                  <a:srgbClr val="4B5C56"/>
+                </a:solidFill>
+                <a:latin typeface="Calibri"/>
+              </a:rPr>
+              <a:t>CIEVS-MT · SIS Clima-Saúde · Código legível · Fontes oficiais</a:t>
+            </a:r>
+          </a:p>
+        </p:txBody>
+      </p:sp>
+      <p:sp>
+        <p:nvSpPr>
+          <p:cNvPr id="8" name="TextBox 7"/>
+          <p:cNvSpPr txBox="1"/>
+          <p:nvPr/>
+        </p:nvSpPr>
+        <p:spPr>
+          <a:xfrm>
+            <a:off x="10241280" y="6492240"/>
+            <a:ext cx="1554480" cy="274320"/>
+          </a:xfrm>
+          <a:prstGeom prst="rect">
+            <a:avLst/>
+          </a:prstGeom>
+          <a:noFill/>
+        </p:spPr>
+        <p:txBody>
+          <a:bodyPr wrap="square">
+            <a:spAutoFit/>
+          </a:bodyPr>
+          <a:lstStyle/>
+          <a:p>
+            <a:pPr algn="r"/>
+            <a:r>
+              <a:rPr sz="1000" b="0">
+                <a:solidFill>
+                  <a:srgbClr val="4B5C56"/>
+                </a:solidFill>
+                <a:latin typeface="Calibri"/>
+              </a:rPr>
+              <a:t>14/18</a:t>
+            </a:r>
+          </a:p>
+        </p:txBody>
+      </p:sp>
+    </p:spTree>
+  </p:cSld>
+  <p:clrMapOvr>
+    <a:masterClrMapping/>
+  </p:clrMapOvr>
+</p:sld>
+</file>
+
+<file path=ppt/slides/slide15.xml><?xml version="1.0" encoding="utf-8"?>
+<p:sld xmlns:a="http://schemas.openxmlformats.org/drawingml/2006/main" xmlns:p="http://schemas.openxmlformats.org/presentationml/2006/main" xmlns:r="http://schemas.openxmlformats.org/officeDocument/2006/relationships">
+  <p:cSld>
+    <p:spTree>
+      <p:nvGrpSpPr>
+        <p:cNvPr id="1" name=""/>
+        <p:cNvGrpSpPr/>
+        <p:nvPr/>
+      </p:nvGrpSpPr>
+      <p:grpSpPr/>
+      <p:sp>
+        <p:nvSpPr>
+          <p:cNvPr id="2" name="Rectangle 1"/>
+          <p:cNvSpPr/>
+          <p:nvPr/>
+        </p:nvSpPr>
+        <p:spPr>
+          <a:xfrm>
+            <a:off x="0" y="0"/>
+            <a:ext cx="12191695" cy="6858000"/>
+          </a:xfrm>
+          <a:prstGeom prst="rect">
+            <a:avLst/>
+          </a:prstGeom>
+          <a:solidFill>
+            <a:srgbClr val="F3F6F4"/>
+          </a:solidFill>
+          <a:ln>
+            <a:noFill/>
+          </a:ln>
+        </p:spPr>
+        <p:style>
+          <a:lnRef idx="1">
+            <a:schemeClr val="accent1"/>
+          </a:lnRef>
+          <a:fillRef idx="3">
+            <a:schemeClr val="accent1"/>
+          </a:fillRef>
+          <a:effectRef idx="2">
+            <a:schemeClr val="accent1"/>
+          </a:effectRef>
+          <a:fontRef idx="minor">
+            <a:schemeClr val="lt1"/>
+          </a:fontRef>
+        </p:style>
+        <p:txBody>
+          <a:bodyPr rtlCol="0" anchor="ctr"/>
+          <a:lstStyle/>
+          <a:p>
+            <a:pPr algn="ctr"/>
+          </a:p>
+        </p:txBody>
+      </p:sp>
+      <p:sp>
+        <p:nvSpPr>
+          <p:cNvPr id="3" name="Rectangle 2"/>
+          <p:cNvSpPr/>
+          <p:nvPr/>
+        </p:nvSpPr>
+        <p:spPr>
+          <a:xfrm>
+            <a:off x="0" y="0"/>
+            <a:ext cx="12191695" cy="960120"/>
+          </a:xfrm>
+          <a:prstGeom prst="rect">
+            <a:avLst/>
+          </a:prstGeom>
+          <a:solidFill>
+            <a:srgbClr val="08352E"/>
+          </a:solidFill>
+          <a:ln>
+            <a:noFill/>
+          </a:ln>
+        </p:spPr>
+        <p:style>
+          <a:lnRef idx="1">
+            <a:schemeClr val="accent1"/>
+          </a:lnRef>
+          <a:fillRef idx="3">
+            <a:schemeClr val="accent1"/>
+          </a:fillRef>
+          <a:effectRef idx="2">
+            <a:schemeClr val="accent1"/>
+          </a:effectRef>
+          <a:fontRef idx="minor">
+            <a:schemeClr val="lt1"/>
+          </a:fontRef>
+        </p:style>
+        <p:txBody>
+          <a:bodyPr rtlCol="0" anchor="ctr"/>
+          <a:lstStyle/>
+          <a:p>
+            <a:pPr algn="ctr"/>
+          </a:p>
+        </p:txBody>
+      </p:sp>
+      <p:sp>
+        <p:nvSpPr>
+          <p:cNvPr id="4" name="TextBox 3"/>
+          <p:cNvSpPr txBox="1"/>
+          <p:nvPr/>
+        </p:nvSpPr>
+        <p:spPr>
+          <a:xfrm>
+            <a:off x="411480" y="201168"/>
+            <a:ext cx="11155680" cy="411480"/>
+          </a:xfrm>
+          <a:prstGeom prst="rect">
+            <a:avLst/>
+          </a:prstGeom>
+          <a:noFill/>
+        </p:spPr>
+        <p:txBody>
+          <a:bodyPr wrap="square">
+            <a:spAutoFit/>
+          </a:bodyPr>
+          <a:lstStyle/>
+          <a:p>
+            <a:pPr algn="l"/>
+            <a:r>
+              <a:rPr sz="2600" b="1">
+                <a:solidFill>
+                  <a:srgbClr val="FFFFFF"/>
+                </a:solidFill>
+                <a:latin typeface="Calibri"/>
+              </a:rPr>
+              <a:t>Mapa das abas do painel</a:t>
+            </a:r>
+          </a:p>
+        </p:txBody>
+      </p:sp>
+      <p:sp>
+        <p:nvSpPr>
+          <p:cNvPr id="5" name="TextBox 4"/>
+          <p:cNvSpPr txBox="1"/>
+          <p:nvPr/>
+        </p:nvSpPr>
+        <p:spPr>
+          <a:xfrm>
+            <a:off x="411480" y="566928"/>
+            <a:ext cx="11155680" cy="320040"/>
+          </a:xfrm>
+          <a:prstGeom prst="rect">
+            <a:avLst/>
+          </a:prstGeom>
+          <a:noFill/>
+        </p:spPr>
+        <p:txBody>
+          <a:bodyPr wrap="square">
+            <a:spAutoFit/>
+          </a:bodyPr>
+          <a:lstStyle/>
+          <a:p>
+            <a:pPr algn="l"/>
+            <a:r>
+              <a:rPr sz="1300" b="0">
+                <a:solidFill>
+                  <a:srgbClr val="C8E6DC"/>
+                </a:solidFill>
+                <a:latin typeface="Calibri"/>
+              </a:rPr>
+              <a:t>Tudo executável — com estado vazio quando a fonte faltar</a:t>
+            </a:r>
+          </a:p>
+        </p:txBody>
+      </p:sp>
+      <p:sp>
+        <p:nvSpPr>
+          <p:cNvPr id="6" name="TextBox 5"/>
+          <p:cNvSpPr txBox="1"/>
+          <p:nvPr/>
+        </p:nvSpPr>
+        <p:spPr>
+          <a:xfrm>
+            <a:off x="502920" y="1234440"/>
+            <a:ext cx="11155680" cy="4754880"/>
+          </a:xfrm>
+          <a:prstGeom prst="rect">
+            <a:avLst/>
+          </a:prstGeom>
+          <a:noFill/>
+        </p:spPr>
+        <p:txBody>
+          <a:bodyPr wrap="square">
+            <a:spAutoFit/>
+          </a:bodyPr>
+          <a:lstStyle/>
+          <a:p>
+            <a:pPr algn="l">
+              <a:spcAft>
+                <a:spcPts val="800"/>
+              </a:spcAft>
+            </a:pPr>
+            <a:r>
+              <a:rPr sz="1700" b="0">
+                <a:solidFill>
+                  <a:srgbClr val="1A2E28"/>
+                </a:solidFill>
+                <a:latin typeface="Calibri"/>
+              </a:rPr>
+              <a:t>• Executivo / Mapas / Clima·TITAN / Ar / Assistência</a:t>
+            </a:r>
+          </a:p>
+          <a:p>
+            <a:pPr algn="l">
+              <a:spcAft>
+                <a:spcPts val="800"/>
+              </a:spcAft>
+            </a:pPr>
+            <a:r>
+              <a:rPr sz="1700" b="0">
+                <a:solidFill>
+                  <a:srgbClr val="1A2E28"/>
+                </a:solidFill>
+                <a:latin typeface="Calibri"/>
+              </a:rPr>
+              <a:t>• Arboviroses / SIVEP / Sentinela / GeoCalor / AdaptaSUS</a:t>
+            </a:r>
+          </a:p>
+          <a:p>
+            <a:pPr algn="l">
+              <a:spcAft>
+                <a:spcPts val="800"/>
+              </a:spcAft>
+            </a:pPr>
+            <a:r>
+              <a:rPr sz="1700" b="0">
+                <a:solidFill>
+                  <a:srgbClr val="1A2E28"/>
+                </a:solidFill>
+                <a:latin typeface="Calibri"/>
+              </a:rPr>
+              <a:t>• Correlação / Cemaden·ANA / Sazonalidade·OR / Operacional</a:t>
+            </a:r>
+          </a:p>
+          <a:p>
+            <a:pPr algn="l">
+              <a:spcAft>
+                <a:spcPts val="800"/>
+              </a:spcAft>
+            </a:pPr>
+            <a:r>
+              <a:rPr sz="1700" b="0">
+                <a:solidFill>
+                  <a:srgbClr val="1A2E28"/>
+                </a:solidFill>
+                <a:latin typeface="Calibri"/>
+              </a:rPr>
+              <a:t>• Geografia / Inteligência / Alertas / Cálculos / Guia</a:t>
+            </a:r>
+          </a:p>
+          <a:p>
+            <a:pPr algn="l">
+              <a:spcAft>
+                <a:spcPts val="800"/>
+              </a:spcAft>
+            </a:pPr>
+            <a:r>
+              <a:rPr sz="1700" b="0">
+                <a:solidFill>
+                  <a:srgbClr val="1A2E28"/>
+                </a:solidFill>
+                <a:latin typeface="Calibri"/>
+              </a:rPr>
+              <a:t>• Regra: aba nunca derruba o painel; informa o que falta e como gerar.</a:t>
+            </a:r>
+          </a:p>
+        </p:txBody>
+      </p:sp>
+      <p:sp>
+        <p:nvSpPr>
+          <p:cNvPr id="7" name="TextBox 6"/>
+          <p:cNvSpPr txBox="1"/>
+          <p:nvPr/>
+        </p:nvSpPr>
+        <p:spPr>
+          <a:xfrm>
+            <a:off x="411480" y="6492240"/>
+            <a:ext cx="9144000" cy="274320"/>
+          </a:xfrm>
+          <a:prstGeom prst="rect">
+            <a:avLst/>
+          </a:prstGeom>
+          <a:noFill/>
+        </p:spPr>
+        <p:txBody>
+          <a:bodyPr wrap="square">
+            <a:spAutoFit/>
+          </a:bodyPr>
+          <a:lstStyle/>
+          <a:p>
+            <a:pPr algn="l"/>
+            <a:r>
+              <a:rPr sz="1000" b="0">
+                <a:solidFill>
+                  <a:srgbClr val="4B5C56"/>
+                </a:solidFill>
+                <a:latin typeface="Calibri"/>
+              </a:rPr>
+              <a:t>CIEVS-MT · SIS Clima-Saúde · Código legível · Fontes oficiais</a:t>
+            </a:r>
+          </a:p>
+        </p:txBody>
+      </p:sp>
+      <p:sp>
+        <p:nvSpPr>
+          <p:cNvPr id="8" name="TextBox 7"/>
+          <p:cNvSpPr txBox="1"/>
+          <p:nvPr/>
+        </p:nvSpPr>
+        <p:spPr>
+          <a:xfrm>
+            <a:off x="10241280" y="6492240"/>
+            <a:ext cx="1554480" cy="274320"/>
+          </a:xfrm>
+          <a:prstGeom prst="rect">
+            <a:avLst/>
+          </a:prstGeom>
+          <a:noFill/>
+        </p:spPr>
+        <p:txBody>
+          <a:bodyPr wrap="square">
+            <a:spAutoFit/>
+          </a:bodyPr>
+          <a:lstStyle/>
+          <a:p>
+            <a:pPr algn="r"/>
+            <a:r>
+              <a:rPr sz="1000" b="0">
+                <a:solidFill>
+                  <a:srgbClr val="4B5C56"/>
+                </a:solidFill>
+                <a:latin typeface="Calibri"/>
+              </a:rPr>
+              <a:t>15/18</a:t>
+            </a:r>
+          </a:p>
+        </p:txBody>
+      </p:sp>
+    </p:spTree>
+  </p:cSld>
+  <p:clrMapOvr>
+    <a:masterClrMapping/>
+  </p:clrMapOvr>
+</p:sld>
+</file>
+
+<file path=ppt/slides/slide16.xml><?xml version="1.0" encoding="utf-8"?>
+<p:sld xmlns:a="http://schemas.openxmlformats.org/drawingml/2006/main" xmlns:p="http://schemas.openxmlformats.org/presentationml/2006/main" xmlns:r="http://schemas.openxmlformats.org/officeDocument/2006/relationships">
+  <p:cSld>
+    <p:spTree>
+      <p:nvGrpSpPr>
+        <p:cNvPr id="1" name=""/>
+        <p:cNvGrpSpPr/>
+        <p:nvPr/>
+      </p:nvGrpSpPr>
+      <p:grpSpPr/>
+      <p:sp>
+        <p:nvSpPr>
+          <p:cNvPr id="2" name="Rectangle 1"/>
+          <p:cNvSpPr/>
+          <p:nvPr/>
+        </p:nvSpPr>
+        <p:spPr>
+          <a:xfrm>
+            <a:off x="0" y="0"/>
+            <a:ext cx="12191695" cy="6858000"/>
+          </a:xfrm>
+          <a:prstGeom prst="rect">
+            <a:avLst/>
+          </a:prstGeom>
+          <a:solidFill>
+            <a:srgbClr val="F3F6F4"/>
+          </a:solidFill>
+          <a:ln>
+            <a:noFill/>
+          </a:ln>
+        </p:spPr>
+        <p:style>
+          <a:lnRef idx="1">
+            <a:schemeClr val="accent1"/>
+          </a:lnRef>
+          <a:fillRef idx="3">
+            <a:schemeClr val="accent1"/>
+          </a:fillRef>
+          <a:effectRef idx="2">
+            <a:schemeClr val="accent1"/>
+          </a:effectRef>
+          <a:fontRef idx="minor">
+            <a:schemeClr val="lt1"/>
+          </a:fontRef>
+        </p:style>
+        <p:txBody>
+          <a:bodyPr rtlCol="0" anchor="ctr"/>
+          <a:lstStyle/>
+          <a:p>
+            <a:pPr algn="ctr"/>
+          </a:p>
+        </p:txBody>
+      </p:sp>
+      <p:sp>
+        <p:nvSpPr>
+          <p:cNvPr id="3" name="Rectangle 2"/>
+          <p:cNvSpPr/>
+          <p:nvPr/>
+        </p:nvSpPr>
+        <p:spPr>
+          <a:xfrm>
+            <a:off x="0" y="0"/>
+            <a:ext cx="12191695" cy="960120"/>
+          </a:xfrm>
+          <a:prstGeom prst="rect">
+            <a:avLst/>
+          </a:prstGeom>
+          <a:solidFill>
+            <a:srgbClr val="08352E"/>
+          </a:solidFill>
+          <a:ln>
+            <a:noFill/>
+          </a:ln>
+        </p:spPr>
+        <p:style>
+          <a:lnRef idx="1">
+            <a:schemeClr val="accent1"/>
+          </a:lnRef>
+          <a:fillRef idx="3">
+            <a:schemeClr val="accent1"/>
+          </a:fillRef>
+          <a:effectRef idx="2">
+            <a:schemeClr val="accent1"/>
+          </a:effectRef>
+          <a:fontRef idx="minor">
+            <a:schemeClr val="lt1"/>
+          </a:fontRef>
+        </p:style>
+        <p:txBody>
+          <a:bodyPr rtlCol="0" anchor="ctr"/>
+          <a:lstStyle/>
+          <a:p>
+            <a:pPr algn="ctr"/>
+          </a:p>
+        </p:txBody>
+      </p:sp>
+      <p:sp>
+        <p:nvSpPr>
+          <p:cNvPr id="4" name="TextBox 3"/>
+          <p:cNvSpPr txBox="1"/>
+          <p:nvPr/>
+        </p:nvSpPr>
+        <p:spPr>
+          <a:xfrm>
+            <a:off x="411480" y="201168"/>
+            <a:ext cx="11155680" cy="411480"/>
+          </a:xfrm>
+          <a:prstGeom prst="rect">
+            <a:avLst/>
+          </a:prstGeom>
+          <a:noFill/>
+        </p:spPr>
+        <p:txBody>
+          <a:bodyPr wrap="square">
+            <a:spAutoFit/>
+          </a:bodyPr>
+          <a:lstStyle/>
+          <a:p>
+            <a:pPr algn="l"/>
+            <a:r>
+              <a:rPr sz="2600" b="1">
+                <a:solidFill>
+                  <a:srgbClr val="FFFFFF"/>
+                </a:solidFill>
+                <a:latin typeface="Calibri"/>
+              </a:rPr>
+              <a:t>Alertas em 4 níveis</a:t>
+            </a:r>
+          </a:p>
+        </p:txBody>
+      </p:sp>
+      <p:sp>
+        <p:nvSpPr>
+          <p:cNvPr id="5" name="TextBox 4"/>
+          <p:cNvSpPr txBox="1"/>
+          <p:nvPr/>
+        </p:nvSpPr>
+        <p:spPr>
+          <a:xfrm>
+            <a:off x="411480" y="566928"/>
+            <a:ext cx="11155680" cy="320040"/>
+          </a:xfrm>
+          <a:prstGeom prst="rect">
+            <a:avLst/>
+          </a:prstGeom>
+          <a:noFill/>
+        </p:spPr>
+        <p:txBody>
+          <a:bodyPr wrap="square">
+            <a:spAutoFit/>
+          </a:bodyPr>
+          <a:lstStyle/>
+          <a:p>
+            <a:pPr algn="l"/>
+            <a:r>
+              <a:rPr sz="1300" b="0">
+                <a:solidFill>
+                  <a:srgbClr val="C8E6DC"/>
+                </a:solidFill>
+                <a:latin typeface="Calibri"/>
+              </a:rPr>
+              <a:t>Ícones · indicadores · predição · orientações por público</a:t>
+            </a:r>
+          </a:p>
+        </p:txBody>
+      </p:sp>
+      <p:sp>
+        <p:nvSpPr>
+          <p:cNvPr id="6" name="Rounded Rectangle 5"/>
+          <p:cNvSpPr/>
+          <p:nvPr/>
+        </p:nvSpPr>
+        <p:spPr>
+          <a:xfrm>
+            <a:off x="411480" y="1234440"/>
+            <a:ext cx="5486400" cy="2103120"/>
+          </a:xfrm>
+          <a:prstGeom prst="roundRect">
+            <a:avLst/>
+          </a:prstGeom>
+          <a:solidFill>
+            <a:srgbClr val="FFFFFF"/>
+          </a:solidFill>
+          <a:ln>
+            <a:solidFill>
+              <a:srgbClr val="D5E0DA"/>
+            </a:solidFill>
+          </a:ln>
+        </p:spPr>
+        <p:style>
+          <a:lnRef idx="1">
+            <a:schemeClr val="accent1"/>
+          </a:lnRef>
+          <a:fillRef idx="3">
+            <a:schemeClr val="accent1"/>
+          </a:fillRef>
+          <a:effectRef idx="2">
+            <a:schemeClr val="accent1"/>
+          </a:effectRef>
+          <a:fontRef idx="minor">
+            <a:schemeClr val="lt1"/>
+          </a:fontRef>
+        </p:style>
+        <p:txBody>
+          <a:bodyPr rtlCol="0" anchor="ctr"/>
+          <a:lstStyle/>
+          <a:p>
+            <a:pPr algn="ctr"/>
+          </a:p>
+        </p:txBody>
+      </p:sp>
+      <p:sp>
+        <p:nvSpPr>
+          <p:cNvPr id="7" name="Rectangle 6"/>
+          <p:cNvSpPr/>
+          <p:nvPr/>
+        </p:nvSpPr>
+        <p:spPr>
+          <a:xfrm>
+            <a:off x="411480" y="1234440"/>
+            <a:ext cx="109728" cy="2103120"/>
+          </a:xfrm>
+          <a:prstGeom prst="rect">
+            <a:avLst/>
+          </a:prstGeom>
+          <a:solidFill>
+            <a:srgbClr val="6D28D9"/>
+          </a:solidFill>
+          <a:ln>
+            <a:noFill/>
+          </a:ln>
+        </p:spPr>
+        <p:style>
+          <a:lnRef idx="1">
+            <a:schemeClr val="accent1"/>
+          </a:lnRef>
+          <a:fillRef idx="3">
+            <a:schemeClr val="accent1"/>
+          </a:fillRef>
+          <a:effectRef idx="2">
+            <a:schemeClr val="accent1"/>
+          </a:effectRef>
+          <a:fontRef idx="minor">
+            <a:schemeClr val="lt1"/>
+          </a:fontRef>
+        </p:style>
+        <p:txBody>
+          <a:bodyPr rtlCol="0" anchor="ctr"/>
+          <a:lstStyle/>
+          <a:p>
+            <a:pPr algn="ctr"/>
+          </a:p>
+        </p:txBody>
+      </p:sp>
+      <p:sp>
+        <p:nvSpPr>
+          <p:cNvPr id="8" name="TextBox 7"/>
+          <p:cNvSpPr txBox="1"/>
+          <p:nvPr/>
+        </p:nvSpPr>
+        <p:spPr>
+          <a:xfrm>
+            <a:off x="667512" y="1371600"/>
+            <a:ext cx="5120640" cy="320040"/>
+          </a:xfrm>
+          <a:prstGeom prst="rect">
+            <a:avLst/>
+          </a:prstGeom>
+          <a:noFill/>
+        </p:spPr>
+        <p:txBody>
+          <a:bodyPr wrap="square">
+            <a:spAutoFit/>
+          </a:bodyPr>
+          <a:lstStyle/>
+          <a:p>
+            <a:pPr algn="l"/>
+            <a:r>
+              <a:rPr sz="1400" b="1">
+                <a:solidFill>
+                  <a:srgbClr val="08352E"/>
+                </a:solidFill>
+                <a:latin typeface="Calibri"/>
+              </a:rPr>
+              <a:t>① Estadual → SES/CIEVS</a:t>
+            </a:r>
+          </a:p>
+        </p:txBody>
+      </p:sp>
+      <p:sp>
+        <p:nvSpPr>
+          <p:cNvPr id="9" name="TextBox 8"/>
+          <p:cNvSpPr txBox="1"/>
+          <p:nvPr/>
+        </p:nvSpPr>
+        <p:spPr>
+          <a:xfrm>
+            <a:off x="667512" y="1691640"/>
+            <a:ext cx="5120640" cy="1508760"/>
+          </a:xfrm>
+          <a:prstGeom prst="rect">
+            <a:avLst/>
+          </a:prstGeom>
+          <a:noFill/>
+        </p:spPr>
+        <p:txBody>
+          <a:bodyPr wrap="square">
+            <a:spAutoFit/>
+          </a:bodyPr>
+          <a:lstStyle/>
+          <a:p>
+            <a:pPr algn="l"/>
+            <a:r>
+              <a:rPr sz="1300" b="0">
+                <a:solidFill>
+                  <a:srgbClr val="1A2E28"/>
+                </a:solidFill>
+                <a:latin typeface="Calibri"/>
+              </a:rPr>
+              <a:t>Boletim do estado com distribuição de níveis e pred 7d.</a:t>
+            </a:r>
+          </a:p>
+        </p:txBody>
+      </p:sp>
+      <p:sp>
+        <p:nvSpPr>
+          <p:cNvPr id="10" name="Rounded Rectangle 9"/>
+          <p:cNvSpPr/>
+          <p:nvPr/>
+        </p:nvSpPr>
+        <p:spPr>
+          <a:xfrm>
+            <a:off x="6126480" y="1234440"/>
+            <a:ext cx="5486400" cy="2103120"/>
+          </a:xfrm>
+          <a:prstGeom prst="roundRect">
+            <a:avLst/>
+          </a:prstGeom>
+          <a:solidFill>
+            <a:srgbClr val="FFFFFF"/>
+          </a:solidFill>
+          <a:ln>
+            <a:solidFill>
+              <a:srgbClr val="D5E0DA"/>
+            </a:solidFill>
+          </a:ln>
+        </p:spPr>
+        <p:style>
+          <a:lnRef idx="1">
+            <a:schemeClr val="accent1"/>
+          </a:lnRef>
+          <a:fillRef idx="3">
+            <a:schemeClr val="accent1"/>
+          </a:fillRef>
+          <a:effectRef idx="2">
+            <a:schemeClr val="accent1"/>
+          </a:effectRef>
+          <a:fontRef idx="minor">
+            <a:schemeClr val="lt1"/>
+          </a:fontRef>
+        </p:style>
+        <p:txBody>
+          <a:bodyPr rtlCol="0" anchor="ctr"/>
+          <a:lstStyle/>
+          <a:p>
+            <a:pPr algn="ctr"/>
+          </a:p>
+        </p:txBody>
+      </p:sp>
+      <p:sp>
+        <p:nvSpPr>
+          <p:cNvPr id="11" name="Rectangle 10"/>
+          <p:cNvSpPr/>
+          <p:nvPr/>
+        </p:nvSpPr>
+        <p:spPr>
+          <a:xfrm>
+            <a:off x="6126480" y="1234440"/>
+            <a:ext cx="109728" cy="2103120"/>
+          </a:xfrm>
+          <a:prstGeom prst="rect">
+            <a:avLst/>
+          </a:prstGeom>
+          <a:solidFill>
+            <a:srgbClr val="DC2626"/>
+          </a:solidFill>
+          <a:ln>
+            <a:noFill/>
+          </a:ln>
+        </p:spPr>
+        <p:style>
+          <a:lnRef idx="1">
+            <a:schemeClr val="accent1"/>
+          </a:lnRef>
+          <a:fillRef idx="3">
+            <a:schemeClr val="accent1"/>
+          </a:fillRef>
+          <a:effectRef idx="2">
+            <a:schemeClr val="accent1"/>
+          </a:effectRef>
+          <a:fontRef idx="minor">
+            <a:schemeClr val="lt1"/>
+          </a:fontRef>
+        </p:style>
+        <p:txBody>
+          <a:bodyPr rtlCol="0" anchor="ctr"/>
+          <a:lstStyle/>
+          <a:p>
+            <a:pPr algn="ctr"/>
+          </a:p>
+        </p:txBody>
+      </p:sp>
+      <p:sp>
+        <p:nvSpPr>
+          <p:cNvPr id="12" name="TextBox 11"/>
+          <p:cNvSpPr txBox="1"/>
+          <p:nvPr/>
+        </p:nvSpPr>
+        <p:spPr>
+          <a:xfrm>
+            <a:off x="6382512" y="1371600"/>
+            <a:ext cx="5120640" cy="320040"/>
+          </a:xfrm>
+          <a:prstGeom prst="rect">
+            <a:avLst/>
+          </a:prstGeom>
+          <a:noFill/>
+        </p:spPr>
+        <p:txBody>
+          <a:bodyPr wrap="square">
+            <a:spAutoFit/>
+          </a:bodyPr>
+          <a:lstStyle/>
+          <a:p>
+            <a:pPr algn="l"/>
+            <a:r>
+              <a:rPr sz="1400" b="1">
+                <a:solidFill>
+                  <a:srgbClr val="08352E"/>
+                </a:solidFill>
+                <a:latin typeface="Calibri"/>
+              </a:rPr>
+              <a:t>② Regional + municípios</a:t>
+            </a:r>
+          </a:p>
+        </p:txBody>
+      </p:sp>
+      <p:sp>
+        <p:nvSpPr>
+          <p:cNvPr id="13" name="TextBox 12"/>
+          <p:cNvSpPr txBox="1"/>
+          <p:nvPr/>
+        </p:nvSpPr>
+        <p:spPr>
+          <a:xfrm>
+            <a:off x="6382512" y="1691640"/>
+            <a:ext cx="5120640" cy="1508760"/>
+          </a:xfrm>
+          <a:prstGeom prst="rect">
+            <a:avLst/>
+          </a:prstGeom>
+          <a:noFill/>
+        </p:spPr>
+        <p:txBody>
+          <a:bodyPr wrap="square">
+            <a:spAutoFit/>
+          </a:bodyPr>
+          <a:lstStyle/>
+          <a:p>
+            <a:pPr algn="l"/>
+            <a:r>
+              <a:rPr sz="1300" b="0">
+                <a:solidFill>
+                  <a:srgbClr val="1A2E28"/>
+                </a:solidFill>
+                <a:latin typeface="Calibri"/>
+              </a:rPr>
+              <a:t>Cada Regional de Saúde e sua jurisdição municipal.</a:t>
+            </a:r>
+          </a:p>
+        </p:txBody>
+      </p:sp>
+      <p:sp>
+        <p:nvSpPr>
+          <p:cNvPr id="14" name="Rounded Rectangle 13"/>
+          <p:cNvSpPr/>
+          <p:nvPr/>
+        </p:nvSpPr>
+        <p:spPr>
+          <a:xfrm>
+            <a:off x="411480" y="3520440"/>
+            <a:ext cx="5486400" cy="2103120"/>
+          </a:xfrm>
+          <a:prstGeom prst="roundRect">
+            <a:avLst/>
+          </a:prstGeom>
+          <a:solidFill>
+            <a:srgbClr val="FFFFFF"/>
+          </a:solidFill>
+          <a:ln>
+            <a:solidFill>
+              <a:srgbClr val="D5E0DA"/>
+            </a:solidFill>
+          </a:ln>
+        </p:spPr>
+        <p:style>
+          <a:lnRef idx="1">
+            <a:schemeClr val="accent1"/>
+          </a:lnRef>
+          <a:fillRef idx="3">
+            <a:schemeClr val="accent1"/>
+          </a:fillRef>
+          <a:effectRef idx="2">
+            <a:schemeClr val="accent1"/>
+          </a:effectRef>
+          <a:fontRef idx="minor">
+            <a:schemeClr val="lt1"/>
+          </a:fontRef>
+        </p:style>
+        <p:txBody>
+          <a:bodyPr rtlCol="0" anchor="ctr"/>
+          <a:lstStyle/>
+          <a:p>
+            <a:pPr algn="ctr"/>
+          </a:p>
+        </p:txBody>
+      </p:sp>
+      <p:sp>
+        <p:nvSpPr>
+          <p:cNvPr id="15" name="Rectangle 14"/>
+          <p:cNvSpPr/>
+          <p:nvPr/>
+        </p:nvSpPr>
+        <p:spPr>
+          <a:xfrm>
+            <a:off x="411480" y="3520440"/>
+            <a:ext cx="109728" cy="2103120"/>
+          </a:xfrm>
+          <a:prstGeom prst="rect">
+            <a:avLst/>
+          </a:prstGeom>
+          <a:solidFill>
+            <a:srgbClr val="D97706"/>
+          </a:solidFill>
+          <a:ln>
+            <a:noFill/>
+          </a:ln>
+        </p:spPr>
+        <p:style>
+          <a:lnRef idx="1">
+            <a:schemeClr val="accent1"/>
+          </a:lnRef>
+          <a:fillRef idx="3">
+            <a:schemeClr val="accent1"/>
+          </a:fillRef>
+          <a:effectRef idx="2">
+            <a:schemeClr val="accent1"/>
+          </a:effectRef>
+          <a:fontRef idx="minor">
+            <a:schemeClr val="lt1"/>
+          </a:fontRef>
+        </p:style>
+        <p:txBody>
+          <a:bodyPr rtlCol="0" anchor="ctr"/>
+          <a:lstStyle/>
+          <a:p>
+            <a:pPr algn="ctr"/>
+          </a:p>
+        </p:txBody>
+      </p:sp>
+      <p:sp>
+        <p:nvSpPr>
+          <p:cNvPr id="16" name="TextBox 15"/>
+          <p:cNvSpPr txBox="1"/>
+          <p:nvPr/>
+        </p:nvSpPr>
+        <p:spPr>
+          <a:xfrm>
+            <a:off x="667512" y="3657600"/>
+            <a:ext cx="5120640" cy="320040"/>
+          </a:xfrm>
+          <a:prstGeom prst="rect">
+            <a:avLst/>
+          </a:prstGeom>
+          <a:noFill/>
+        </p:spPr>
+        <p:txBody>
+          <a:bodyPr wrap="square">
+            <a:spAutoFit/>
+          </a:bodyPr>
+          <a:lstStyle/>
+          <a:p>
+            <a:pPr algn="l"/>
+            <a:r>
+              <a:rPr sz="1400" b="1">
+                <a:solidFill>
+                  <a:srgbClr val="08352E"/>
+                </a:solidFill>
+                <a:latin typeface="Calibri"/>
+              </a:rPr>
+              <a:t>③ Municipal</a:t>
+            </a:r>
+          </a:p>
+        </p:txBody>
+      </p:sp>
+      <p:sp>
+        <p:nvSpPr>
+          <p:cNvPr id="17" name="TextBox 16"/>
+          <p:cNvSpPr txBox="1"/>
+          <p:nvPr/>
+        </p:nvSpPr>
+        <p:spPr>
+          <a:xfrm>
+            <a:off x="667512" y="3977639"/>
+            <a:ext cx="5120640" cy="1508760"/>
+          </a:xfrm>
+          <a:prstGeom prst="rect">
+            <a:avLst/>
+          </a:prstGeom>
+          <a:noFill/>
+        </p:spPr>
+        <p:txBody>
+          <a:bodyPr wrap="square">
+            <a:spAutoFit/>
+          </a:bodyPr>
+          <a:lstStyle/>
+          <a:p>
+            <a:pPr algn="l"/>
+            <a:r>
+              <a:rPr sz="1300" b="0">
+                <a:solidFill>
+                  <a:srgbClr val="1A2E28"/>
+                </a:solidFill>
+                <a:latin typeface="Calibri"/>
+              </a:rPr>
+              <a:t>SMS/plantão — a partir do nível mínimo (ex.: laranja).</a:t>
+            </a:r>
+          </a:p>
+        </p:txBody>
+      </p:sp>
+      <p:sp>
+        <p:nvSpPr>
+          <p:cNvPr id="18" name="Rounded Rectangle 17"/>
+          <p:cNvSpPr/>
+          <p:nvPr/>
+        </p:nvSpPr>
+        <p:spPr>
+          <a:xfrm>
+            <a:off x="6126480" y="3520440"/>
+            <a:ext cx="5486400" cy="2103120"/>
+          </a:xfrm>
+          <a:prstGeom prst="roundRect">
+            <a:avLst/>
+          </a:prstGeom>
+          <a:solidFill>
+            <a:srgbClr val="FFFFFF"/>
+          </a:solidFill>
+          <a:ln>
+            <a:solidFill>
+              <a:srgbClr val="D5E0DA"/>
+            </a:solidFill>
+          </a:ln>
+        </p:spPr>
+        <p:style>
+          <a:lnRef idx="1">
+            <a:schemeClr val="accent1"/>
+          </a:lnRef>
+          <a:fillRef idx="3">
+            <a:schemeClr val="accent1"/>
+          </a:fillRef>
+          <a:effectRef idx="2">
+            <a:schemeClr val="accent1"/>
+          </a:effectRef>
+          <a:fontRef idx="minor">
+            <a:schemeClr val="lt1"/>
+          </a:fontRef>
+        </p:style>
+        <p:txBody>
+          <a:bodyPr rtlCol="0" anchor="ctr"/>
+          <a:lstStyle/>
+          <a:p>
+            <a:pPr algn="ctr"/>
+          </a:p>
+        </p:txBody>
+      </p:sp>
+      <p:sp>
+        <p:nvSpPr>
+          <p:cNvPr id="19" name="Rectangle 18"/>
+          <p:cNvSpPr/>
+          <p:nvPr/>
+        </p:nvSpPr>
+        <p:spPr>
+          <a:xfrm>
+            <a:off x="6126480" y="3520440"/>
+            <a:ext cx="109728" cy="2103120"/>
+          </a:xfrm>
+          <a:prstGeom prst="rect">
+            <a:avLst/>
+          </a:prstGeom>
+          <a:solidFill>
+            <a:srgbClr val="0F6E56"/>
+          </a:solidFill>
+          <a:ln>
+            <a:noFill/>
+          </a:ln>
+        </p:spPr>
+        <p:style>
+          <a:lnRef idx="1">
+            <a:schemeClr val="accent1"/>
+          </a:lnRef>
+          <a:fillRef idx="3">
+            <a:schemeClr val="accent1"/>
+          </a:fillRef>
+          <a:effectRef idx="2">
+            <a:schemeClr val="accent1"/>
+          </a:effectRef>
+          <a:fontRef idx="minor">
+            <a:schemeClr val="lt1"/>
+          </a:fontRef>
+        </p:style>
+        <p:txBody>
+          <a:bodyPr rtlCol="0" anchor="ctr"/>
+          <a:lstStyle/>
+          <a:p>
+            <a:pPr algn="ctr"/>
+          </a:p>
+        </p:txBody>
+      </p:sp>
+      <p:sp>
+        <p:nvSpPr>
+          <p:cNvPr id="20" name="TextBox 19"/>
+          <p:cNvSpPr txBox="1"/>
+          <p:nvPr/>
+        </p:nvSpPr>
+        <p:spPr>
+          <a:xfrm>
+            <a:off x="6382512" y="3657600"/>
+            <a:ext cx="5120640" cy="320040"/>
+          </a:xfrm>
+          <a:prstGeom prst="rect">
+            <a:avLst/>
+          </a:prstGeom>
+          <a:noFill/>
+        </p:spPr>
+        <p:txBody>
+          <a:bodyPr wrap="square">
+            <a:spAutoFit/>
+          </a:bodyPr>
+          <a:lstStyle/>
+          <a:p>
+            <a:pPr algn="l"/>
+            <a:r>
+              <a:rPr sz="1400" b="1">
+                <a:solidFill>
+                  <a:srgbClr val="08352E"/>
+                </a:solidFill>
+                <a:latin typeface="Calibri"/>
+              </a:rPr>
+              <a:t>④ Vigidesastre Cuiabá</a:t>
+            </a:r>
+          </a:p>
+        </p:txBody>
+      </p:sp>
+      <p:sp>
+        <p:nvSpPr>
+          <p:cNvPr id="21" name="TextBox 20"/>
+          <p:cNvSpPr txBox="1"/>
+          <p:nvPr/>
+        </p:nvSpPr>
+        <p:spPr>
+          <a:xfrm>
+            <a:off x="6382512" y="3977639"/>
+            <a:ext cx="5120640" cy="1508760"/>
+          </a:xfrm>
+          <a:prstGeom prst="rect">
+            <a:avLst/>
+          </a:prstGeom>
+          <a:noFill/>
+        </p:spPr>
+        <p:txBody>
+          <a:bodyPr wrap="square">
+            <a:spAutoFit/>
+          </a:bodyPr>
+          <a:lstStyle/>
+          <a:p>
+            <a:pPr algn="l"/>
+            <a:r>
+              <a:rPr sz="1300" b="0">
+                <a:solidFill>
+                  <a:srgbClr val="1A2E28"/>
+                </a:solidFill>
+                <a:latin typeface="Calibri"/>
+              </a:rPr>
+              <a:t>Pacote dedicado IBGE 5103403 com as mesmas seções.</a:t>
+            </a:r>
+          </a:p>
+        </p:txBody>
+      </p:sp>
+      <p:sp>
+        <p:nvSpPr>
+          <p:cNvPr id="22" name="TextBox 21"/>
+          <p:cNvSpPr txBox="1"/>
+          <p:nvPr/>
+        </p:nvSpPr>
+        <p:spPr>
+          <a:xfrm>
+            <a:off x="411480" y="6492240"/>
+            <a:ext cx="9144000" cy="274320"/>
+          </a:xfrm>
+          <a:prstGeom prst="rect">
+            <a:avLst/>
+          </a:prstGeom>
+          <a:noFill/>
+        </p:spPr>
+        <p:txBody>
+          <a:bodyPr wrap="square">
+            <a:spAutoFit/>
+          </a:bodyPr>
+          <a:lstStyle/>
+          <a:p>
+            <a:pPr algn="l"/>
+            <a:r>
+              <a:rPr sz="1000" b="0">
+                <a:solidFill>
+                  <a:srgbClr val="4B5C56"/>
+                </a:solidFill>
+                <a:latin typeface="Calibri"/>
+              </a:rPr>
+              <a:t>CIEVS-MT · SIS Clima-Saúde · Código legível · Fontes oficiais</a:t>
+            </a:r>
+          </a:p>
+        </p:txBody>
+      </p:sp>
+      <p:sp>
+        <p:nvSpPr>
+          <p:cNvPr id="23" name="TextBox 22"/>
+          <p:cNvSpPr txBox="1"/>
+          <p:nvPr/>
+        </p:nvSpPr>
+        <p:spPr>
+          <a:xfrm>
+            <a:off x="10241280" y="6492240"/>
+            <a:ext cx="1554480" cy="274320"/>
+          </a:xfrm>
+          <a:prstGeom prst="rect">
+            <a:avLst/>
+          </a:prstGeom>
+          <a:noFill/>
+        </p:spPr>
+        <p:txBody>
+          <a:bodyPr wrap="square">
+            <a:spAutoFit/>
+          </a:bodyPr>
+          <a:lstStyle/>
+          <a:p>
+            <a:pPr algn="r"/>
+            <a:r>
+              <a:rPr sz="1000" b="0">
+                <a:solidFill>
+                  <a:srgbClr val="4B5C56"/>
+                </a:solidFill>
+                <a:latin typeface="Calibri"/>
+              </a:rPr>
+              <a:t>16/18</a:t>
+            </a:r>
+          </a:p>
+        </p:txBody>
+      </p:sp>
+    </p:spTree>
+  </p:cSld>
+  <p:clrMapOvr>
+    <a:masterClrMapping/>
+  </p:clrMapOvr>
+</p:sld>
+</file>
+
+<file path=ppt/slides/slide17.xml><?xml version="1.0" encoding="utf-8"?>
+<p:sld xmlns:a="http://schemas.openxmlformats.org/drawingml/2006/main" xmlns:p="http://schemas.openxmlformats.org/presentationml/2006/main" xmlns:r="http://schemas.openxmlformats.org/officeDocument/2006/relationships">
+  <p:cSld>
+    <p:spTree>
+      <p:nvGrpSpPr>
+        <p:cNvPr id="1" name=""/>
+        <p:cNvGrpSpPr/>
+        <p:nvPr/>
+      </p:nvGrpSpPr>
+      <p:grpSpPr/>
+      <p:sp>
+        <p:nvSpPr>
+          <p:cNvPr id="2" name="Rectangle 1"/>
+          <p:cNvSpPr/>
+          <p:nvPr/>
+        </p:nvSpPr>
+        <p:spPr>
+          <a:xfrm>
+            <a:off x="0" y="0"/>
+            <a:ext cx="12191695" cy="6858000"/>
+          </a:xfrm>
+          <a:prstGeom prst="rect">
+            <a:avLst/>
+          </a:prstGeom>
+          <a:solidFill>
+            <a:srgbClr val="F3F6F4"/>
+          </a:solidFill>
+          <a:ln>
+            <a:noFill/>
+          </a:ln>
+        </p:spPr>
+        <p:style>
+          <a:lnRef idx="1">
+            <a:schemeClr val="accent1"/>
+          </a:lnRef>
+          <a:fillRef idx="3">
+            <a:schemeClr val="accent1"/>
+          </a:fillRef>
+          <a:effectRef idx="2">
+            <a:schemeClr val="accent1"/>
+          </a:effectRef>
+          <a:fontRef idx="minor">
+            <a:schemeClr val="lt1"/>
+          </a:fontRef>
+        </p:style>
+        <p:txBody>
+          <a:bodyPr rtlCol="0" anchor="ctr"/>
+          <a:lstStyle/>
+          <a:p>
+            <a:pPr algn="ctr"/>
+          </a:p>
+        </p:txBody>
+      </p:sp>
+      <p:sp>
+        <p:nvSpPr>
+          <p:cNvPr id="3" name="Rectangle 2"/>
+          <p:cNvSpPr/>
+          <p:nvPr/>
+        </p:nvSpPr>
+        <p:spPr>
+          <a:xfrm>
+            <a:off x="0" y="0"/>
+            <a:ext cx="12191695" cy="960120"/>
+          </a:xfrm>
+          <a:prstGeom prst="rect">
+            <a:avLst/>
+          </a:prstGeom>
+          <a:solidFill>
+            <a:srgbClr val="08352E"/>
+          </a:solidFill>
+          <a:ln>
+            <a:noFill/>
+          </a:ln>
+        </p:spPr>
+        <p:style>
+          <a:lnRef idx="1">
+            <a:schemeClr val="accent1"/>
+          </a:lnRef>
+          <a:fillRef idx="3">
+            <a:schemeClr val="accent1"/>
+          </a:fillRef>
+          <a:effectRef idx="2">
+            <a:schemeClr val="accent1"/>
+          </a:effectRef>
+          <a:fontRef idx="minor">
+            <a:schemeClr val="lt1"/>
+          </a:fontRef>
+        </p:style>
+        <p:txBody>
+          <a:bodyPr rtlCol="0" anchor="ctr"/>
+          <a:lstStyle/>
+          <a:p>
+            <a:pPr algn="ctr"/>
+          </a:p>
+        </p:txBody>
+      </p:sp>
+      <p:sp>
+        <p:nvSpPr>
+          <p:cNvPr id="4" name="TextBox 3"/>
+          <p:cNvSpPr txBox="1"/>
+          <p:nvPr/>
+        </p:nvSpPr>
+        <p:spPr>
+          <a:xfrm>
+            <a:off x="411480" y="201168"/>
+            <a:ext cx="11155680" cy="411480"/>
+          </a:xfrm>
+          <a:prstGeom prst="rect">
+            <a:avLst/>
+          </a:prstGeom>
+          <a:noFill/>
+        </p:spPr>
+        <p:txBody>
+          <a:bodyPr wrap="square">
+            <a:spAutoFit/>
+          </a:bodyPr>
+          <a:lstStyle/>
+          <a:p>
+            <a:pPr algn="l"/>
+            <a:r>
+              <a:rPr sz="2600" b="1">
+                <a:solidFill>
+                  <a:srgbClr val="FFFFFF"/>
+                </a:solidFill>
+                <a:latin typeface="Calibri"/>
+              </a:rPr>
+              <a:t>Próximos passos</a:t>
+            </a:r>
+          </a:p>
+        </p:txBody>
+      </p:sp>
+      <p:sp>
+        <p:nvSpPr>
+          <p:cNvPr id="5" name="TextBox 4"/>
+          <p:cNvSpPr txBox="1"/>
+          <p:nvPr/>
+        </p:nvSpPr>
+        <p:spPr>
+          <a:xfrm>
+            <a:off x="411480" y="566928"/>
+            <a:ext cx="11155680" cy="320040"/>
+          </a:xfrm>
+          <a:prstGeom prst="rect">
+            <a:avLst/>
+          </a:prstGeom>
+          <a:noFill/>
+        </p:spPr>
+        <p:txBody>
+          <a:bodyPr wrap="square">
+            <a:spAutoFit/>
+          </a:bodyPr>
+          <a:lstStyle/>
+          <a:p>
+            <a:pPr algn="l"/>
+            <a:r>
+              <a:rPr sz="1300" b="0">
+                <a:solidFill>
+                  <a:srgbClr val="C8E6DC"/>
+                </a:solidFill>
+                <a:latin typeface="Calibri"/>
+              </a:rPr>
+              <a:t>Do painel à rotina do CIEVS</a:t>
+            </a:r>
+          </a:p>
+        </p:txBody>
+      </p:sp>
+      <p:sp>
+        <p:nvSpPr>
+          <p:cNvPr id="6" name="TextBox 5"/>
+          <p:cNvSpPr txBox="1"/>
+          <p:nvPr/>
+        </p:nvSpPr>
+        <p:spPr>
+          <a:xfrm>
+            <a:off x="502920" y="1280160"/>
+            <a:ext cx="11155680" cy="4572000"/>
+          </a:xfrm>
+          <a:prstGeom prst="rect">
+            <a:avLst/>
+          </a:prstGeom>
+          <a:noFill/>
+        </p:spPr>
+        <p:txBody>
+          <a:bodyPr wrap="square">
+            <a:spAutoFit/>
+          </a:bodyPr>
+          <a:lstStyle/>
+          <a:p>
+            <a:pPr algn="l">
+              <a:spcAft>
+                <a:spcPts val="800"/>
+              </a:spcAft>
+            </a:pPr>
+            <a:r>
+              <a:rPr sz="1700" b="0">
+                <a:solidFill>
+                  <a:srgbClr val="1A2E28"/>
+                </a:solidFill>
+                <a:latin typeface="Calibri"/>
+              </a:rPr>
+              <a:t>• Padronizar abertura do painel no plantão (checklist de 5 minutos).</a:t>
+            </a:r>
+          </a:p>
+          <a:p>
+            <a:pPr algn="l">
+              <a:spcAft>
+                <a:spcPts val="800"/>
+              </a:spcAft>
+            </a:pPr>
+            <a:r>
+              <a:rPr sz="1700" b="0">
+                <a:solidFill>
+                  <a:srgbClr val="1A2E28"/>
+                </a:solidFill>
+                <a:latin typeface="Calibri"/>
+              </a:rPr>
+              <a:t>• Validar boletins multinível no painel antes de armar SEND_ALERT.</a:t>
+            </a:r>
+          </a:p>
+          <a:p>
+            <a:pPr algn="l">
+              <a:spcAft>
+                <a:spcPts val="800"/>
+              </a:spcAft>
+            </a:pPr>
+            <a:r>
+              <a:rPr sz="1700" b="0">
+                <a:solidFill>
+                  <a:srgbClr val="1A2E28"/>
+                </a:solidFill>
+                <a:latin typeface="Calibri"/>
+              </a:rPr>
+              <a:t>• Completar CSV de contatos (estadual/regional/municipal/Cuiabá).</a:t>
+            </a:r>
+          </a:p>
+          <a:p>
+            <a:pPr algn="l">
+              <a:spcAft>
+                <a:spcPts val="800"/>
+              </a:spcAft>
+            </a:pPr>
+            <a:r>
+              <a:rPr sz="1700" b="0">
+                <a:solidFill>
+                  <a:srgbClr val="1A2E28"/>
+                </a:solidFill>
+                <a:latin typeface="Calibri"/>
+              </a:rPr>
+              <a:t>• Expandir nowcasting/forecasting e séries SIM/GAL/GeoCalor no Postgres.</a:t>
+            </a:r>
+          </a:p>
+          <a:p>
+            <a:pPr algn="l">
+              <a:spcAft>
+                <a:spcPts val="800"/>
+              </a:spcAft>
+            </a:pPr>
+            <a:r>
+              <a:rPr sz="1700" b="0">
+                <a:solidFill>
+                  <a:srgbClr val="1A2E28"/>
+                </a:solidFill>
+                <a:latin typeface="Calibri"/>
+              </a:rPr>
+              <a:t>• Articular indicadores do SIS aos gatilhos do Plano de Contingência.</a:t>
+            </a:r>
+          </a:p>
+        </p:txBody>
+      </p:sp>
+      <p:sp>
+        <p:nvSpPr>
+          <p:cNvPr id="7" name="TextBox 6"/>
+          <p:cNvSpPr txBox="1"/>
+          <p:nvPr/>
+        </p:nvSpPr>
+        <p:spPr>
+          <a:xfrm>
+            <a:off x="411480" y="6492240"/>
+            <a:ext cx="9144000" cy="274320"/>
+          </a:xfrm>
+          <a:prstGeom prst="rect">
+            <a:avLst/>
+          </a:prstGeom>
+          <a:noFill/>
+        </p:spPr>
+        <p:txBody>
+          <a:bodyPr wrap="square">
+            <a:spAutoFit/>
+          </a:bodyPr>
+          <a:lstStyle/>
+          <a:p>
+            <a:pPr algn="l"/>
+            <a:r>
+              <a:rPr sz="1000" b="0">
+                <a:solidFill>
+                  <a:srgbClr val="4B5C56"/>
+                </a:solidFill>
+                <a:latin typeface="Calibri"/>
+              </a:rPr>
+              <a:t>CIEVS-MT · SIS Clima-Saúde · Código legível · Fontes oficiais</a:t>
+            </a:r>
+          </a:p>
+        </p:txBody>
+      </p:sp>
+      <p:sp>
+        <p:nvSpPr>
+          <p:cNvPr id="8" name="TextBox 7"/>
+          <p:cNvSpPr txBox="1"/>
+          <p:nvPr/>
+        </p:nvSpPr>
+        <p:spPr>
+          <a:xfrm>
+            <a:off x="10241280" y="6492240"/>
+            <a:ext cx="1554480" cy="274320"/>
+          </a:xfrm>
+          <a:prstGeom prst="rect">
+            <a:avLst/>
+          </a:prstGeom>
+          <a:noFill/>
+        </p:spPr>
+        <p:txBody>
+          <a:bodyPr wrap="square">
+            <a:spAutoFit/>
+          </a:bodyPr>
+          <a:lstStyle/>
+          <a:p>
+            <a:pPr algn="r"/>
+            <a:r>
+              <a:rPr sz="1000" b="0">
+                <a:solidFill>
+                  <a:srgbClr val="4B5C56"/>
+                </a:solidFill>
+                <a:latin typeface="Calibri"/>
+              </a:rPr>
+              <a:t>17/18</a:t>
+            </a:r>
+          </a:p>
+        </p:txBody>
+      </p:sp>
+    </p:spTree>
+  </p:cSld>
+  <p:clrMapOvr>
+    <a:masterClrMapping/>
+  </p:clrMapOvr>
+</p:sld>
+</file>
+
+<file path=ppt/slides/slide18.xml><?xml version="1.0" encoding="utf-8"?>
+<p:sld xmlns:a="http://schemas.openxmlformats.org/drawingml/2006/main" xmlns:p="http://schemas.openxmlformats.org/presentationml/2006/main" xmlns:r="http://schemas.openxmlformats.org/officeDocument/2006/relationships">
+  <p:cSld>
+    <p:spTree>
+      <p:nvGrpSpPr>
+        <p:cNvPr id="1" name=""/>
+        <p:cNvGrpSpPr/>
+        <p:nvPr/>
+      </p:nvGrpSpPr>
+      <p:grpSpPr/>
+      <p:sp>
+        <p:nvSpPr>
+          <p:cNvPr id="2" name="Rectangle 1"/>
+          <p:cNvSpPr/>
+          <p:nvPr/>
+        </p:nvSpPr>
+        <p:spPr>
+          <a:xfrm>
+            <a:off x="0" y="0"/>
+            <a:ext cx="12191695" cy="6858000"/>
+          </a:xfrm>
+          <a:prstGeom prst="rect">
+            <a:avLst/>
+          </a:prstGeom>
+          <a:solidFill>
+            <a:srgbClr val="08352E"/>
+          </a:solidFill>
+          <a:ln>
+            <a:noFill/>
+          </a:ln>
+        </p:spPr>
+        <p:style>
+          <a:lnRef idx="1">
+            <a:schemeClr val="accent1"/>
+          </a:lnRef>
+          <a:fillRef idx="3">
+            <a:schemeClr val="accent1"/>
+          </a:fillRef>
+          <a:effectRef idx="2">
+            <a:schemeClr val="accent1"/>
+          </a:effectRef>
+          <a:fontRef idx="minor">
+            <a:schemeClr val="lt1"/>
+          </a:fontRef>
+        </p:style>
+        <p:txBody>
+          <a:bodyPr rtlCol="0" anchor="ctr"/>
+          <a:lstStyle/>
+          <a:p>
+            <a:pPr algn="ctr"/>
+          </a:p>
+        </p:txBody>
+      </p:sp>
+      <p:sp>
+        <p:nvSpPr>
+          <p:cNvPr id="3" name="TextBox 2"/>
+          <p:cNvSpPr txBox="1"/>
+          <p:nvPr/>
+        </p:nvSpPr>
+        <p:spPr>
+          <a:xfrm>
+            <a:off x="640080" y="1828800"/>
+            <a:ext cx="10972800" cy="731520"/>
+          </a:xfrm>
+          <a:prstGeom prst="rect">
+            <a:avLst/>
+          </a:prstGeom>
+          <a:noFill/>
+        </p:spPr>
+        <p:txBody>
+          <a:bodyPr wrap="square">
+            <a:spAutoFit/>
+          </a:bodyPr>
+          <a:lstStyle/>
+          <a:p>
+            <a:pPr algn="l"/>
+            <a:r>
+              <a:rPr sz="4000" b="1">
+                <a:solidFill>
+                  <a:srgbClr val="FFFFFF"/>
+                </a:solidFill>
+                <a:latin typeface="Calibri"/>
+              </a:rPr>
+              <a:t>Obrigado</a:t>
+            </a:r>
+          </a:p>
+        </p:txBody>
+      </p:sp>
+      <p:sp>
+        <p:nvSpPr>
+          <p:cNvPr id="4" name="TextBox 3"/>
+          <p:cNvSpPr txBox="1"/>
+          <p:nvPr/>
+        </p:nvSpPr>
+        <p:spPr>
+          <a:xfrm>
+            <a:off x="640080" y="2743200"/>
+            <a:ext cx="10972800" cy="1371600"/>
+          </a:xfrm>
+          <a:prstGeom prst="rect">
+            <a:avLst/>
+          </a:prstGeom>
+          <a:noFill/>
+        </p:spPr>
+        <p:txBody>
+          <a:bodyPr wrap="square">
+            <a:spAutoFit/>
+          </a:bodyPr>
+          <a:lstStyle/>
+          <a:p>
+            <a:pPr algn="l"/>
+            <a:r>
+              <a:rPr sz="2000" b="0">
+                <a:solidFill>
+                  <a:srgbClr val="D7EBE3"/>
+                </a:solidFill>
+                <a:latin typeface="Calibri"/>
+              </a:rPr>
+              <a:t>SIS Clima-Saúde MT — vigilância para decidir a tempo.
+Perguntas e encaminhamentos.</a:t>
+            </a:r>
+          </a:p>
+        </p:txBody>
+      </p:sp>
+      <p:sp>
+        <p:nvSpPr>
+          <p:cNvPr id="5" name="TextBox 4"/>
+          <p:cNvSpPr txBox="1"/>
+          <p:nvPr/>
+        </p:nvSpPr>
+        <p:spPr>
+          <a:xfrm>
+            <a:off x="640080" y="4754880"/>
+            <a:ext cx="10972800" cy="914400"/>
+          </a:xfrm>
+          <a:prstGeom prst="rect">
+            <a:avLst/>
+          </a:prstGeom>
+          <a:noFill/>
+        </p:spPr>
+        <p:txBody>
+          <a:bodyPr wrap="square">
+            <a:spAutoFit/>
+          </a:bodyPr>
+          <a:lstStyle/>
+          <a:p>
+            <a:pPr algn="l"/>
+            <a:r>
               <a:rPr sz="1400" b="0">
                 <a:solidFill>
                   <a:srgbClr val="A8C7BC"/>
@@ -6390,7 +9157,7 @@
                 <a:latin typeface="Calibri"/>
               </a:rPr>
               <a:t>CIEVS-MT · SES-MT
-Painel: streamlit_app.py · Documentação em docs/</a:t>
+Painel: http://localhost:8501 · docs/VISAO_OPERACIONAL_SIS_CLIMA_SAUDE.md</a:t>
             </a:r>
           </a:p>
         </p:txBody>
@@ -6737,7 +9504,7 @@
                 </a:solidFill>
                 <a:latin typeface="Calibri"/>
               </a:rPr>
-              <a:t>2/14</a:t>
+              <a:t>2/18</a:t>
             </a:r>
           </a:p>
         </p:txBody>
@@ -7226,7 +9993,7 @@
                 </a:solidFill>
                 <a:latin typeface="Calibri"/>
               </a:rPr>
-              <a:t>3/14</a:t>
+              <a:t>3/18</a:t>
             </a:r>
           </a:p>
         </p:txBody>
@@ -7944,7 +10711,7 @@
                 </a:solidFill>
                 <a:latin typeface="Calibri"/>
               </a:rPr>
-              <a:t>4/14</a:t>
+              <a:t>4/18</a:t>
             </a:r>
           </a:p>
         </p:txBody>
@@ -8291,7 +11058,7 @@
                 </a:solidFill>
                 <a:latin typeface="Calibri"/>
               </a:rPr>
-              <a:t>5/14</a:t>
+              <a:t>5/18</a:t>
             </a:r>
           </a:p>
         </p:txBody>
@@ -9483,7 +12250,7 @@
                 </a:solidFill>
                 <a:latin typeface="Calibri"/>
               </a:rPr>
-              <a:t>6/14</a:t>
+              <a:t>6/18</a:t>
             </a:r>
           </a:p>
         </p:txBody>
@@ -10517,7 +13284,7 @@
                 </a:solidFill>
                 <a:latin typeface="Calibri"/>
               </a:rPr>
-              <a:t>7/14</a:t>
+              <a:t>7/18</a:t>
             </a:r>
           </a:p>
         </p:txBody>
@@ -10993,7 +13760,7 @@
                 </a:solidFill>
                 <a:latin typeface="Calibri"/>
               </a:rPr>
-              <a:t>8/14</a:t>
+              <a:t>8/18</a:t>
             </a:r>
           </a:p>
         </p:txBody>
@@ -11324,7 +14091,7 @@
                 </a:solidFill>
                 <a:latin typeface="Calibri"/>
               </a:rPr>
-              <a:t>9/14</a:t>
+              <a:t>9/18</a:t>
             </a:r>
           </a:p>
         </p:txBody>

</xml_diff>